<commit_message>
Sunum: mimari slaytı hibrit RAG çerçevesine göre güncellendi (AI Search + Azure SQL → Foundry)
Co-Authored-By: Claude Opus 5.5 <noreply@anthropic.com>
Claude-Session: https://claude.ai/code/session_01DTiHxbPkixs9Jadunw7PB9
</commit_message>
<xml_diff>
--- a/presentation/Mercek_AI_Overflow_Sunum.pptx
+++ b/presentation/Mercek_AI_Overflow_Sunum.pptx
@@ -1029,7 +1029,7 @@
           <a:lstStyle/>
           <a:p>
             <a:r>
-              <a:t>0:58–1:05 · İki App Service (web ve api), Foundry'de sohbet ve embedding modeli, SQL yapısal veri, AI Search hibrit arama. CI/CD her PR'da test ve güvenlik taraması yapıyor. Sağda AI'ın ve kuralların işi. (Yalnızca gerçekten çalışan servisler bu slaytta kalmalı.)</a:t>
+              <a:t>0:58–1:05 · Mercek hibrit RAG kullanır: AI Search geçmiş çözümleri, talepleri ve duyuruları anlam benzerliğiyle bulur (vektör + kelime, Türkçe analizör, Foundry embedding); Azure SQL o anki gerçek rakamları parametreli sorgularla getirir. Foundry ikisini bağlam olarak alıp cevabı yazar; rakam uydurmaz çünkü her sayı SQL'den gelir. Model SQL yazmaz (text-to-SQL yok). CI/CD her PR'da test ve güvenlik taraması yapıyor. Sağda AI'ın ve kuralların işi. (Yalnızca gerçekten çalışan servisler bu slaytta kalmalı.)</a:t>
             </a:r>
           </a:p>
         </p:txBody>
@@ -5139,7 +5139,7 @@
                 </a:solidFill>
                 <a:latin typeface="Calibri"/>
               </a:rPr>
-              <a:t>Azure: 2 App Service, Foundry, SQL, AI Search</a:t>
+              <a:t>Azure: 2 App Service, Foundry, hibrit RAG (AI Search + SQL)</a:t>
             </a:r>
           </a:p>
           <a:p>
@@ -10418,7 +10418,7 @@
                 </a:solidFill>
                 <a:latin typeface="Calibri"/>
               </a:rPr>
-              <a:t>Mimari: Azure Üzerinde Uçtan Uca</a:t>
+              <a:t>Mimari: Azure Üzerinde Hibrit RAG</a:t>
             </a:r>
           </a:p>
         </p:txBody>
@@ -10534,7 +10534,7 @@
         <p:spPr>
           <a:xfrm>
             <a:off x="411480" y="2148840"/>
-            <a:ext cx="1783080" cy="2377440"/>
+            <a:ext cx="1463040" cy="2377440"/>
           </a:xfrm>
           <a:prstGeom prst="roundRect">
             <a:avLst>
@@ -10563,8 +10563,8 @@
         </p:nvSpPr>
         <p:spPr>
           <a:xfrm>
-            <a:off x="502920" y="2194560"/>
-            <a:ext cx="1600200" cy="2286000"/>
+            <a:off x="484632" y="2194560"/>
+            <a:ext cx="1316736" cy="2286000"/>
           </a:xfrm>
           <a:prstGeom prst="rect">
             <a:avLst/>
@@ -10605,9 +10605,11 @@
                 </a:solidFill>
                 <a:latin typeface="Calibri"/>
               </a:rPr>
-              <a:t>Şube, çağrı merkezi
+              <a:t>Şube, çağrı
+merkezi
 L2 destek
-İş birimi, analist</a:t>
+İş birimi,
+analist</a:t>
             </a:r>
           </a:p>
         </p:txBody>
@@ -10620,8 +10622,8 @@
         </p:nvSpPr>
         <p:spPr>
           <a:xfrm>
-            <a:off x="2697480" y="1234440"/>
-            <a:ext cx="2377440" cy="1600200"/>
+            <a:off x="2103120" y="1234440"/>
+            <a:ext cx="2103120" cy="1600200"/>
           </a:xfrm>
           <a:prstGeom prst="roundRect">
             <a:avLst>
@@ -10650,8 +10652,8 @@
         </p:nvSpPr>
         <p:spPr>
           <a:xfrm>
-            <a:off x="2788920" y="1280160"/>
-            <a:ext cx="2194560" cy="1508760"/>
+            <a:off x="2176272" y="1280160"/>
+            <a:ext cx="1956815" cy="1508760"/>
           </a:xfrm>
           <a:prstGeom prst="rect">
             <a:avLst/>
@@ -10694,7 +10696,7 @@
               </a:rPr>
               <a:t>Next.js 16
 Bankacılık ekranları,
-Mercek, Talep Yönlendirme</a:t>
+Mercek, Talep</a:t>
             </a:r>
           </a:p>
         </p:txBody>
@@ -10707,8 +10709,8 @@
         </p:nvSpPr>
         <p:spPr>
           <a:xfrm>
-            <a:off x="2697480" y="3794760"/>
-            <a:ext cx="2377440" cy="1600200"/>
+            <a:off x="2103120" y="3794760"/>
+            <a:ext cx="2103120" cy="1600200"/>
           </a:xfrm>
           <a:prstGeom prst="roundRect">
             <a:avLst>
@@ -10737,8 +10739,8 @@
         </p:nvSpPr>
         <p:spPr>
           <a:xfrm>
-            <a:off x="2788920" y="3840480"/>
-            <a:ext cx="2194560" cy="1508760"/>
+            <a:off x="2176272" y="3840480"/>
+            <a:ext cx="1956815" cy="1508760"/>
           </a:xfrm>
           <a:prstGeom prst="rect">
             <a:avLst/>
@@ -10794,8 +10796,8 @@
         </p:nvSpPr>
         <p:spPr>
           <a:xfrm>
-            <a:off x="5532120" y="1234440"/>
-            <a:ext cx="2514600" cy="1234440"/>
+            <a:off x="4434840" y="1097280"/>
+            <a:ext cx="3749039" cy="4343400"/>
           </a:xfrm>
           <a:prstGeom prst="roundRect">
             <a:avLst>
@@ -10804,6 +10806,175 @@
           </a:prstGeom>
           <a:solidFill>
             <a:srgbClr val="FFFFFF"/>
+          </a:solidFill>
+          <a:ln w="15875">
+            <a:solidFill>
+              <a:srgbClr val="E10514"/>
+            </a:solidFill>
+          </a:ln>
+          <a:effectLst/>
+        </p:spPr>
+        <p:txBody>
+          <a:bodyPr rtlCol="0" anchor="ctr"/>
+          <a:lstStyle/>
+          <a:p/>
+        </p:txBody>
+      </p:sp>
+      <p:sp>
+        <p:nvSpPr>
+          <p:cNvPr id="13" name="TextBox 12"/>
+          <p:cNvSpPr txBox="1"/>
+          <p:nvPr/>
+        </p:nvSpPr>
+        <p:spPr>
+          <a:xfrm>
+            <a:off x="4572000" y="1133856"/>
+            <a:ext cx="3474720" cy="365760"/>
+          </a:xfrm>
+          <a:prstGeom prst="rect">
+            <a:avLst/>
+          </a:prstGeom>
+          <a:noFill/>
+        </p:spPr>
+        <p:txBody>
+          <a:bodyPr wrap="square" anchor="ctr" lIns="0" rIns="0" tIns="0" bIns="0">
+            <a:spAutoFit/>
+          </a:bodyPr>
+          <a:lstStyle/>
+          <a:p>
+            <a:pPr algn="l">
+              <a:spcAft>
+                <a:spcPts val="400"/>
+              </a:spcAft>
+            </a:pPr>
+            <a:r>
+              <a:rPr sz="1300" b="1" i="0">
+                <a:solidFill>
+                  <a:srgbClr val="E10514"/>
+                </a:solidFill>
+                <a:latin typeface="Calibri"/>
+              </a:rPr>
+              <a:t>HİBRİT RAG  </a:t>
+            </a:r>
+            <a:r>
+              <a:rPr sz="1100" b="0" i="0">
+                <a:solidFill>
+                  <a:srgbClr val="91969B"/>
+                </a:solidFill>
+                <a:latin typeface="Calibri"/>
+              </a:rPr>
+              <a:t>1 getir · 2 bağlam · 3 üret</a:t>
+            </a:r>
+          </a:p>
+        </p:txBody>
+      </p:sp>
+      <p:sp>
+        <p:nvSpPr>
+          <p:cNvPr id="14" name="Rounded Rectangle 13"/>
+          <p:cNvSpPr/>
+          <p:nvPr/>
+        </p:nvSpPr>
+        <p:spPr>
+          <a:xfrm>
+            <a:off x="4572000" y="1554480"/>
+            <a:ext cx="2103120" cy="1463040"/>
+          </a:xfrm>
+          <a:prstGeom prst="roundRect">
+            <a:avLst>
+              <a:gd name="adj" fmla="val 6000"/>
+            </a:avLst>
+          </a:prstGeom>
+          <a:solidFill>
+            <a:srgbClr val="F2F5F6"/>
+          </a:solidFill>
+          <a:ln w="15875">
+            <a:solidFill>
+              <a:srgbClr val="E10514"/>
+            </a:solidFill>
+          </a:ln>
+          <a:effectLst/>
+        </p:spPr>
+        <p:txBody>
+          <a:bodyPr rtlCol="0" anchor="ctr"/>
+          <a:lstStyle/>
+          <a:p/>
+        </p:txBody>
+      </p:sp>
+      <p:sp>
+        <p:nvSpPr>
+          <p:cNvPr id="15" name="TextBox 14"/>
+          <p:cNvSpPr txBox="1"/>
+          <p:nvPr/>
+        </p:nvSpPr>
+        <p:spPr>
+          <a:xfrm>
+            <a:off x="4645152" y="1600200"/>
+            <a:ext cx="1956815" cy="1371600"/>
+          </a:xfrm>
+          <a:prstGeom prst="rect">
+            <a:avLst/>
+          </a:prstGeom>
+          <a:noFill/>
+        </p:spPr>
+        <p:txBody>
+          <a:bodyPr wrap="square" anchor="ctr" lIns="0" rIns="0" tIns="0" bIns="0">
+            <a:spAutoFit/>
+          </a:bodyPr>
+          <a:lstStyle/>
+          <a:p>
+            <a:pPr algn="ctr">
+              <a:spcAft>
+                <a:spcPts val="200"/>
+              </a:spcAft>
+            </a:pPr>
+            <a:r>
+              <a:rPr sz="1400" b="1" i="0">
+                <a:solidFill>
+                  <a:srgbClr val="1E1E1E"/>
+                </a:solidFill>
+                <a:latin typeface="Calibri"/>
+              </a:rPr>
+              <a:t>Azure AI Search</a:t>
+            </a:r>
+          </a:p>
+          <a:p>
+            <a:pPr algn="ctr">
+              <a:spcAft>
+                <a:spcPts val="200"/>
+              </a:spcAft>
+            </a:pPr>
+            <a:r>
+              <a:rPr sz="1100" b="0" i="0">
+                <a:solidFill>
+                  <a:srgbClr val="1E1E1E"/>
+                </a:solidFill>
+                <a:latin typeface="Calibri"/>
+              </a:rPr>
+              <a:t>1 · anlamca getir
+çözüm · talep · duyuru
+vektör + kelime, Türkçe</a:t>
+            </a:r>
+          </a:p>
+        </p:txBody>
+      </p:sp>
+      <p:sp>
+        <p:nvSpPr>
+          <p:cNvPr id="16" name="Rounded Rectangle 15"/>
+          <p:cNvSpPr/>
+          <p:nvPr/>
+        </p:nvSpPr>
+        <p:spPr>
+          <a:xfrm>
+            <a:off x="4572000" y="3154680"/>
+            <a:ext cx="2103120" cy="1325880"/>
+          </a:xfrm>
+          <a:prstGeom prst="roundRect">
+            <a:avLst>
+              <a:gd name="adj" fmla="val 6000"/>
+            </a:avLst>
+          </a:prstGeom>
+          <a:solidFill>
+            <a:srgbClr val="F2F5F6"/>
           </a:solidFill>
           <a:ln w="15875">
             <a:solidFill>
@@ -10820,14 +10991,14 @@
       </p:sp>
       <p:sp>
         <p:nvSpPr>
-          <p:cNvPr id="13" name="TextBox 12"/>
+          <p:cNvPr id="17" name="TextBox 16"/>
           <p:cNvSpPr txBox="1"/>
           <p:nvPr/>
         </p:nvSpPr>
         <p:spPr>
           <a:xfrm>
-            <a:off x="5623559" y="1280160"/>
-            <a:ext cx="2331720" cy="1143000"/>
+            <a:off x="4645152" y="3200400"/>
+            <a:ext cx="1956815" cy="1234439"/>
           </a:xfrm>
           <a:prstGeom prst="rect">
             <a:avLst/>
@@ -10846,13 +11017,13 @@
               </a:spcAft>
             </a:pPr>
             <a:r>
-              <a:rPr sz="1500" b="1" i="0">
+              <a:rPr sz="1400" b="1" i="0">
                 <a:solidFill>
                   <a:srgbClr val="1E1E1E"/>
                 </a:solidFill>
                 <a:latin typeface="Calibri"/>
               </a:rPr>
-              <a:t>Azure AI Foundry</a:t>
+              <a:t>Azure SQL</a:t>
             </a:r>
           </a:p>
           <a:p>
@@ -10862,27 +11033,29 @@
               </a:spcAft>
             </a:pPr>
             <a:r>
-              <a:rPr sz="1200" b="0" i="0">
+              <a:rPr sz="1100" b="0" i="0">
                 <a:solidFill>
                   <a:srgbClr val="1E1E1E"/>
                 </a:solidFill>
                 <a:latin typeface="Calibri"/>
               </a:rPr>
-              <a:t>chat + embedding modeli</a:t>
-            </a:r>
-          </a:p>
-        </p:txBody>
-      </p:sp>
-      <p:sp>
-        <p:nvSpPr>
-          <p:cNvPr id="14" name="Rounded Rectangle 13"/>
+              <a:t>1 · rakamı getir
+log · çağrı · portföy · takvim
+parametreli sorgu</a:t>
+            </a:r>
+          </a:p>
+        </p:txBody>
+      </p:sp>
+      <p:sp>
+        <p:nvSpPr>
+          <p:cNvPr id="18" name="Rounded Rectangle 17"/>
           <p:cNvSpPr/>
           <p:nvPr/>
         </p:nvSpPr>
         <p:spPr>
           <a:xfrm>
-            <a:off x="5532120" y="2697480"/>
-            <a:ext cx="2514600" cy="1234440"/>
+            <a:off x="6903720" y="1554480"/>
+            <a:ext cx="1143000" cy="2926080"/>
           </a:xfrm>
           <a:prstGeom prst="roundRect">
             <a:avLst>
@@ -10890,12 +11063,10 @@
             </a:avLst>
           </a:prstGeom>
           <a:solidFill>
-            <a:srgbClr val="FFFFFF"/>
+            <a:srgbClr val="E10514"/>
           </a:solidFill>
-          <a:ln w="15875">
-            <a:solidFill>
-              <a:srgbClr val="B4BEC3"/>
-            </a:solidFill>
+          <a:ln>
+            <a:noFill/>
           </a:ln>
           <a:effectLst/>
         </p:spPr>
@@ -10907,14 +11078,14 @@
       </p:sp>
       <p:sp>
         <p:nvSpPr>
-          <p:cNvPr id="15" name="TextBox 14"/>
+          <p:cNvPr id="19" name="TextBox 18"/>
           <p:cNvSpPr txBox="1"/>
           <p:nvPr/>
         </p:nvSpPr>
         <p:spPr>
           <a:xfrm>
-            <a:off x="5623559" y="2743200"/>
-            <a:ext cx="2331720" cy="1143000"/>
+            <a:off x="6976872" y="1600200"/>
+            <a:ext cx="996696" cy="2834640"/>
           </a:xfrm>
           <a:prstGeom prst="rect">
             <a:avLst/>
@@ -10933,13 +11104,13 @@
               </a:spcAft>
             </a:pPr>
             <a:r>
-              <a:rPr sz="1500" b="1" i="0">
-                <a:solidFill>
-                  <a:srgbClr val="1E1E1E"/>
-                </a:solidFill>
-                <a:latin typeface="Calibri"/>
-              </a:rPr>
-              <a:t>Azure SQL</a:t>
+              <a:rPr sz="1300" b="1" i="0">
+                <a:solidFill>
+                  <a:srgbClr val="FFFFFF"/>
+                </a:solidFill>
+                <a:latin typeface="Calibri"/>
+              </a:rPr>
+              <a:t>Azure AI Foundry</a:t>
             </a:r>
           </a:p>
           <a:p>
@@ -10949,60 +11120,29 @@
               </a:spcAft>
             </a:pPr>
             <a:r>
-              <a:rPr sz="1200" b="0" i="0">
-                <a:solidFill>
-                  <a:srgbClr val="1E1E1E"/>
-                </a:solidFill>
-                <a:latin typeface="Calibri"/>
-              </a:rPr>
-              <a:t>Log, katalog, portföy,
-çağrı, talep, takvim</a:t>
-            </a:r>
-          </a:p>
-        </p:txBody>
-      </p:sp>
-      <p:sp>
-        <p:nvSpPr>
-          <p:cNvPr id="16" name="Rounded Rectangle 15"/>
-          <p:cNvSpPr/>
-          <p:nvPr/>
-        </p:nvSpPr>
-        <p:spPr>
-          <a:xfrm>
-            <a:off x="5532120" y="4160520"/>
-            <a:ext cx="2514600" cy="1234440"/>
-          </a:xfrm>
-          <a:prstGeom prst="roundRect">
-            <a:avLst>
-              <a:gd name="adj" fmla="val 6000"/>
-            </a:avLst>
-          </a:prstGeom>
-          <a:solidFill>
-            <a:srgbClr val="FFFFFF"/>
-          </a:solidFill>
-          <a:ln w="15875">
-            <a:solidFill>
-              <a:srgbClr val="B4BEC3"/>
-            </a:solidFill>
-          </a:ln>
-          <a:effectLst/>
-        </p:spPr>
-        <p:txBody>
-          <a:bodyPr rtlCol="0" anchor="ctr"/>
-          <a:lstStyle/>
-          <a:p/>
-        </p:txBody>
-      </p:sp>
-      <p:sp>
-        <p:nvSpPr>
-          <p:cNvPr id="17" name="TextBox 16"/>
+              <a:rPr sz="1100" b="0" i="0">
+                <a:solidFill>
+                  <a:srgbClr val="FFFFFF"/>
+                </a:solidFill>
+                <a:latin typeface="Calibri"/>
+              </a:rPr>
+              <a:t>2 · bağlam
+3 · chat ile üret
+embedding → indeks</a:t>
+            </a:r>
+          </a:p>
+        </p:txBody>
+      </p:sp>
+      <p:sp>
+        <p:nvSpPr>
+          <p:cNvPr id="20" name="TextBox 19"/>
           <p:cNvSpPr txBox="1"/>
           <p:nvPr/>
         </p:nvSpPr>
         <p:spPr>
           <a:xfrm>
-            <a:off x="5623559" y="4206240"/>
-            <a:ext cx="2331720" cy="1143000"/>
+            <a:off x="4572000" y="4572000"/>
+            <a:ext cx="3474720" cy="822960"/>
           </a:xfrm>
           <a:prstGeom prst="rect">
             <a:avLst/>
@@ -11015,148 +11155,23 @@
           </a:bodyPr>
           <a:lstStyle/>
           <a:p>
-            <a:pPr algn="ctr">
-              <a:spcAft>
-                <a:spcPts val="200"/>
-              </a:spcAft>
-            </a:pPr>
-            <a:r>
-              <a:rPr sz="1500" b="1" i="0">
+            <a:pPr algn="l">
+              <a:spcAft>
+                <a:spcPts val="400"/>
+              </a:spcAft>
+            </a:pPr>
+            <a:r>
+              <a:rPr sz="1100" b="0" i="0">
                 <a:solidFill>
                   <a:srgbClr val="1E1E1E"/>
                 </a:solidFill>
                 <a:latin typeface="Calibri"/>
               </a:rPr>
-              <a:t>Azure AI Search</a:t>
-            </a:r>
-          </a:p>
-          <a:p>
-            <a:pPr algn="ctr">
-              <a:spcAft>
-                <a:spcPts val="200"/>
-              </a:spcAft>
-            </a:pPr>
-            <a:r>
-              <a:rPr sz="1200" b="0" i="0">
-                <a:solidFill>
-                  <a:srgbClr val="1E1E1E"/>
-                </a:solidFill>
-                <a:latin typeface="Calibri"/>
-              </a:rPr>
-              <a:t>Çözüm, talep, duyuru
-hibrit arama</a:t>
-            </a:r>
-          </a:p>
-        </p:txBody>
-      </p:sp>
-      <p:cxnSp>
-        <p:nvCxnSpPr>
-          <p:cNvPr id="18" name="Connector 17"/>
-          <p:cNvCxnSpPr/>
-          <p:nvPr/>
-        </p:nvCxnSpPr>
-        <p:spPr>
-          <a:xfrm flipV="1">
-            <a:off x="2194560" y="2057400"/>
-            <a:ext cx="502920" cy="685800"/>
-          </a:xfrm>
-          <a:prstGeom prst="line">
-            <a:avLst/>
-          </a:prstGeom>
-          <a:ln w="22225">
-            <a:solidFill>
-              <a:srgbClr val="91969B"/>
-            </a:solidFill>
-            <a:tailEnd type="triangle"/>
-          </a:ln>
-        </p:spPr>
-        <p:style>
-          <a:lnRef idx="2">
-            <a:schemeClr val="accent1"/>
-          </a:lnRef>
-          <a:fillRef idx="0">
-            <a:schemeClr val="accent1"/>
-          </a:fillRef>
-          <a:effectRef idx="1">
-            <a:schemeClr val="accent1"/>
-          </a:effectRef>
-          <a:fontRef idx="minor">
-            <a:schemeClr val="tx1"/>
-          </a:fontRef>
-        </p:style>
-      </p:cxnSp>
-      <p:cxnSp>
-        <p:nvCxnSpPr>
-          <p:cNvPr id="19" name="Connector 18"/>
-          <p:cNvCxnSpPr/>
-          <p:nvPr/>
-        </p:nvCxnSpPr>
-        <p:spPr>
-          <a:xfrm>
-            <a:off x="3886200" y="2834640"/>
-            <a:ext cx="0" cy="960120"/>
-          </a:xfrm>
-          <a:prstGeom prst="line">
-            <a:avLst/>
-          </a:prstGeom>
-          <a:ln w="22225">
-            <a:solidFill>
-              <a:srgbClr val="91969B"/>
-            </a:solidFill>
-            <a:tailEnd type="triangle"/>
-          </a:ln>
-        </p:spPr>
-        <p:style>
-          <a:lnRef idx="2">
-            <a:schemeClr val="accent1"/>
-          </a:lnRef>
-          <a:fillRef idx="0">
-            <a:schemeClr val="accent1"/>
-          </a:fillRef>
-          <a:effectRef idx="1">
-            <a:schemeClr val="accent1"/>
-          </a:effectRef>
-          <a:fontRef idx="minor">
-            <a:schemeClr val="tx1"/>
-          </a:fontRef>
-        </p:style>
-      </p:cxnSp>
-      <p:cxnSp>
-        <p:nvCxnSpPr>
-          <p:cNvPr id="20" name="Connector 19"/>
-          <p:cNvCxnSpPr/>
-          <p:nvPr/>
-        </p:nvCxnSpPr>
-        <p:spPr>
-          <a:xfrm flipV="1">
-            <a:off x="5074920" y="1847088"/>
-            <a:ext cx="457200" cy="2359152"/>
-          </a:xfrm>
-          <a:prstGeom prst="line">
-            <a:avLst/>
-          </a:prstGeom>
-          <a:ln w="22225">
-            <a:solidFill>
-              <a:srgbClr val="91969B"/>
-            </a:solidFill>
-            <a:tailEnd type="triangle"/>
-          </a:ln>
-        </p:spPr>
-        <p:style>
-          <a:lnRef idx="2">
-            <a:schemeClr val="accent1"/>
-          </a:lnRef>
-          <a:fillRef idx="0">
-            <a:schemeClr val="accent1"/>
-          </a:fillRef>
-          <a:effectRef idx="1">
-            <a:schemeClr val="accent1"/>
-          </a:effectRef>
-          <a:fontRef idx="minor">
-            <a:schemeClr val="tx1"/>
-          </a:fontRef>
-        </p:style>
-      </p:cxnSp>
+              <a:t>Benzeri AI Search bulur, rakamı SQL verir; model yalnızca bu kaynaklı bağlamla yazar ve her cevapta kaynak no'su gösterir.</a:t>
+            </a:r>
+          </a:p>
+        </p:txBody>
+      </p:sp>
       <p:cxnSp>
         <p:nvCxnSpPr>
           <p:cNvPr id="21" name="Connector 20"/>
@@ -11165,8 +11180,8 @@
         </p:nvCxnSpPr>
         <p:spPr>
           <a:xfrm flipV="1">
-            <a:off x="5074920" y="3310128"/>
-            <a:ext cx="457200" cy="1261872"/>
+            <a:off x="1874519" y="2057400"/>
+            <a:ext cx="228601" cy="685800"/>
           </a:xfrm>
           <a:prstGeom prst="line">
             <a:avLst/>
@@ -11200,9 +11215,9 @@
           <p:nvPr/>
         </p:nvCxnSpPr>
         <p:spPr>
-          <a:xfrm flipV="1">
-            <a:off x="5074920" y="4773168"/>
-            <a:ext cx="457200" cy="73152"/>
+          <a:xfrm>
+            <a:off x="3154680" y="2834640"/>
+            <a:ext cx="0" cy="960120"/>
           </a:xfrm>
           <a:prstGeom prst="line">
             <a:avLst/>
@@ -11229,9 +11244,153 @@
           </a:fontRef>
         </p:style>
       </p:cxnSp>
-      <p:sp>
-        <p:nvSpPr>
-          <p:cNvPr id="23" name="Rounded Rectangle 22"/>
+      <p:cxnSp>
+        <p:nvCxnSpPr>
+          <p:cNvPr id="23" name="Connector 22"/>
+          <p:cNvCxnSpPr/>
+          <p:nvPr/>
+        </p:nvCxnSpPr>
+        <p:spPr>
+          <a:xfrm flipV="1">
+            <a:off x="4206240" y="2286000"/>
+            <a:ext cx="365760" cy="2011680"/>
+          </a:xfrm>
+          <a:prstGeom prst="line">
+            <a:avLst/>
+          </a:prstGeom>
+          <a:ln w="22225">
+            <a:solidFill>
+              <a:srgbClr val="91969B"/>
+            </a:solidFill>
+            <a:tailEnd type="triangle"/>
+          </a:ln>
+        </p:spPr>
+        <p:style>
+          <a:lnRef idx="2">
+            <a:schemeClr val="accent1"/>
+          </a:lnRef>
+          <a:fillRef idx="0">
+            <a:schemeClr val="accent1"/>
+          </a:fillRef>
+          <a:effectRef idx="1">
+            <a:schemeClr val="accent1"/>
+          </a:effectRef>
+          <a:fontRef idx="minor">
+            <a:schemeClr val="tx1"/>
+          </a:fontRef>
+        </p:style>
+      </p:cxnSp>
+      <p:cxnSp>
+        <p:nvCxnSpPr>
+          <p:cNvPr id="24" name="Connector 23"/>
+          <p:cNvCxnSpPr/>
+          <p:nvPr/>
+        </p:nvCxnSpPr>
+        <p:spPr>
+          <a:xfrm flipV="1">
+            <a:off x="4206240" y="3813048"/>
+            <a:ext cx="365760" cy="758952"/>
+          </a:xfrm>
+          <a:prstGeom prst="line">
+            <a:avLst/>
+          </a:prstGeom>
+          <a:ln w="22225">
+            <a:solidFill>
+              <a:srgbClr val="91969B"/>
+            </a:solidFill>
+            <a:tailEnd type="triangle"/>
+          </a:ln>
+        </p:spPr>
+        <p:style>
+          <a:lnRef idx="2">
+            <a:schemeClr val="accent1"/>
+          </a:lnRef>
+          <a:fillRef idx="0">
+            <a:schemeClr val="accent1"/>
+          </a:fillRef>
+          <a:effectRef idx="1">
+            <a:schemeClr val="accent1"/>
+          </a:effectRef>
+          <a:fontRef idx="minor">
+            <a:schemeClr val="tx1"/>
+          </a:fontRef>
+        </p:style>
+      </p:cxnSp>
+      <p:cxnSp>
+        <p:nvCxnSpPr>
+          <p:cNvPr id="25" name="Connector 24"/>
+          <p:cNvCxnSpPr/>
+          <p:nvPr/>
+        </p:nvCxnSpPr>
+        <p:spPr>
+          <a:xfrm>
+            <a:off x="6675120" y="2286000"/>
+            <a:ext cx="228600" cy="365760"/>
+          </a:xfrm>
+          <a:prstGeom prst="line">
+            <a:avLst/>
+          </a:prstGeom>
+          <a:ln w="22225">
+            <a:solidFill>
+              <a:srgbClr val="E10514"/>
+            </a:solidFill>
+            <a:tailEnd type="triangle"/>
+          </a:ln>
+        </p:spPr>
+        <p:style>
+          <a:lnRef idx="2">
+            <a:schemeClr val="accent1"/>
+          </a:lnRef>
+          <a:fillRef idx="0">
+            <a:schemeClr val="accent1"/>
+          </a:fillRef>
+          <a:effectRef idx="1">
+            <a:schemeClr val="accent1"/>
+          </a:effectRef>
+          <a:fontRef idx="minor">
+            <a:schemeClr val="tx1"/>
+          </a:fontRef>
+        </p:style>
+      </p:cxnSp>
+      <p:cxnSp>
+        <p:nvCxnSpPr>
+          <p:cNvPr id="26" name="Connector 25"/>
+          <p:cNvCxnSpPr/>
+          <p:nvPr/>
+        </p:nvCxnSpPr>
+        <p:spPr>
+          <a:xfrm flipV="1">
+            <a:off x="6675120" y="3383280"/>
+            <a:ext cx="228600" cy="429768"/>
+          </a:xfrm>
+          <a:prstGeom prst="line">
+            <a:avLst/>
+          </a:prstGeom>
+          <a:ln w="22225">
+            <a:solidFill>
+              <a:srgbClr val="E10514"/>
+            </a:solidFill>
+            <a:tailEnd type="triangle"/>
+          </a:ln>
+        </p:spPr>
+        <p:style>
+          <a:lnRef idx="2">
+            <a:schemeClr val="accent1"/>
+          </a:lnRef>
+          <a:fillRef idx="0">
+            <a:schemeClr val="accent1"/>
+          </a:fillRef>
+          <a:effectRef idx="1">
+            <a:schemeClr val="accent1"/>
+          </a:effectRef>
+          <a:fontRef idx="minor">
+            <a:schemeClr val="tx1"/>
+          </a:fontRef>
+        </p:style>
+      </p:cxnSp>
+      <p:sp>
+        <p:nvSpPr>
+          <p:cNvPr id="27" name="Rounded Rectangle 26"/>
           <p:cNvSpPr/>
           <p:nvPr/>
         </p:nvSpPr>
@@ -11261,7 +11420,7 @@
       </p:sp>
       <p:pic>
         <p:nvPicPr>
-          <p:cNvPr id="24" name="Picture 23" descr="github-g.png"/>
+          <p:cNvPr id="28" name="Picture 27" descr="github-g.png"/>
           <p:cNvPicPr>
             <a:picLocks noChangeAspect="1"/>
           </p:cNvPicPr>
@@ -11285,7 +11444,7 @@
       </p:pic>
       <p:sp>
         <p:nvSpPr>
-          <p:cNvPr id="25" name="TextBox 24"/>
+          <p:cNvPr id="29" name="TextBox 28"/>
           <p:cNvSpPr txBox="1"/>
           <p:nvPr/>
         </p:nvSpPr>
@@ -11351,7 +11510,7 @@
       </p:sp>
       <p:sp>
         <p:nvSpPr>
-          <p:cNvPr id="26" name="Rounded Rectangle 25"/>
+          <p:cNvPr id="30" name="Rounded Rectangle 29"/>
           <p:cNvSpPr/>
           <p:nvPr/>
         </p:nvSpPr>
@@ -11381,7 +11540,7 @@
       </p:sp>
       <p:sp>
         <p:nvSpPr>
-          <p:cNvPr id="27" name="TextBox 26"/>
+          <p:cNvPr id="31" name="TextBox 30"/>
           <p:cNvSpPr txBox="1"/>
           <p:nvPr/>
         </p:nvSpPr>
@@ -11500,7 +11659,7 @@
       </p:sp>
       <p:sp>
         <p:nvSpPr>
-          <p:cNvPr id="28" name="Rounded Rectangle 27"/>
+          <p:cNvPr id="32" name="Rounded Rectangle 31"/>
           <p:cNvSpPr/>
           <p:nvPr/>
         </p:nvSpPr>
@@ -11530,7 +11689,7 @@
       </p:sp>
       <p:sp>
         <p:nvSpPr>
-          <p:cNvPr id="29" name="TextBox 28"/>
+          <p:cNvPr id="33" name="TextBox 32"/>
           <p:cNvSpPr txBox="1"/>
           <p:nvPr/>
         </p:nvSpPr>

</xml_diff>

<commit_message>
AI Search ↔ Azure SQL otomatik eşitleme (indexer + integrated vectorization) ve dokümanı
- db.py/schema.sql: solutions, requests, announcements için hesaplanan search_text kolonu; değişiklik takibi
- search.py: veri kaynağı (SqlIntegratedChangeTracking), skillset (AzureOpenAIEmbeddingSkill), vektörleştiricili
  indeks, indexer (PT5M); setup_indexers, wait_indexers, sync_now; requests.status filtresi
- load_all.py: --search varsayılan indexer modu, --search-mode push yedeği, --sync
- demo_reset.py: --sync-search · validate_scenarios.py: SQL ↔ AI Search eşitlik kontrolü, D/E 'tamamlandi' filtresi
- 6 yeni test (toplam 49) · data/out/mercek.db yeniden üretildi
- docs/mercek-sql-search-esitleme.md: temel bilgiler, kurulum ve yetki adımları, demo akışı, sorun giderme
- Mimari slaytı: SQL → AI Search 'indexer · otomatik'

Co-Authored-By: Claude Opus 5.5 <noreply@anthropic.com>
Claude-Session: https://claude.ai/code/session_01DTiHxbPkixs9Jadunw7PB9
</commit_message>
<xml_diff>
--- a/presentation/Mercek_AI_Overflow_Sunum.pptx
+++ b/presentation/Mercek_AI_Overflow_Sunum.pptx
@@ -1029,7 +1029,7 @@
           <a:lstStyle/>
           <a:p>
             <a:r>
-              <a:t>0:58–1:05 · Mercek hibrit RAG kullanır: AI Search geçmiş çözümleri, talepleri ve duyuruları anlam benzerliğiyle bulur (vektör + kelime, Türkçe analizör, Foundry embedding); Azure SQL o anki gerçek rakamları parametreli sorgularla getirir. Foundry ikisini bağlam olarak alıp cevabı yazar; rakam uydurmaz çünkü her sayı SQL'den gelir. Model SQL yazmaz (text-to-SQL yok). CI/CD her PR'da test ve güvenlik taraması yapıyor. Sağda AI'ın ve kuralların işi. (Yalnızca gerçekten çalışan servisler bu slaytta kalmalı.)</a:t>
+              <a:t>0:58–1:05 · Mercek hibrit RAG kullanır: AI Search geçmiş çözümleri, talepleri ve duyuruları anlam benzerliğiyle bulur (vektör + kelime, Türkçe analizör, Foundry embedding); Azure SQL o anki gerçek rakamları parametreli sorgularla getirir. SQL'e yazılan çözüm ve talepler AI Search indexer'ıyla birkaç dakikada kendiliğinden indekse girer; embedding'i Search, Foundry ile kendisi üretir. Foundry ikisini bağlam olarak alıp cevabı yazar; rakam uydurmaz çünkü her sayı SQL'den gelir. Model SQL yazmaz (text-to-SQL yok). CI/CD her PR'da test ve güvenlik taraması yapıyor. Sağda AI'ın ve kuralların işi. (Yalnızca gerçekten çalışan servisler bu slaytta kalmalı.)</a:t>
             </a:r>
           </a:p>
         </p:txBody>
@@ -11316,9 +11316,78 @@
           </a:fontRef>
         </p:style>
       </p:cxnSp>
+      <p:sp>
+        <p:nvSpPr>
+          <p:cNvPr id="25" name="Rounded Rectangle 24"/>
+          <p:cNvSpPr/>
+          <p:nvPr/>
+        </p:nvSpPr>
+        <p:spPr>
+          <a:xfrm>
+            <a:off x="4892040" y="2944368"/>
+            <a:ext cx="1463040" cy="274320"/>
+          </a:xfrm>
+          <a:prstGeom prst="roundRect">
+            <a:avLst>
+              <a:gd name="adj" fmla="val 50000"/>
+            </a:avLst>
+          </a:prstGeom>
+          <a:solidFill>
+            <a:srgbClr val="870F00"/>
+          </a:solidFill>
+          <a:ln>
+            <a:noFill/>
+          </a:ln>
+          <a:effectLst/>
+        </p:spPr>
+        <p:txBody>
+          <a:bodyPr rtlCol="0" anchor="ctr"/>
+          <a:lstStyle/>
+          <a:p/>
+        </p:txBody>
+      </p:sp>
+      <p:sp>
+        <p:nvSpPr>
+          <p:cNvPr id="26" name="TextBox 25"/>
+          <p:cNvSpPr txBox="1"/>
+          <p:nvPr/>
+        </p:nvSpPr>
+        <p:spPr>
+          <a:xfrm>
+            <a:off x="4892040" y="2944368"/>
+            <a:ext cx="1463040" cy="274320"/>
+          </a:xfrm>
+          <a:prstGeom prst="rect">
+            <a:avLst/>
+          </a:prstGeom>
+          <a:noFill/>
+        </p:spPr>
+        <p:txBody>
+          <a:bodyPr wrap="square" anchor="ctr" lIns="0" rIns="0" tIns="0" bIns="0">
+            <a:spAutoFit/>
+          </a:bodyPr>
+          <a:lstStyle/>
+          <a:p>
+            <a:pPr algn="ctr">
+              <a:spcAft>
+                <a:spcPts val="400"/>
+              </a:spcAft>
+            </a:pPr>
+            <a:r>
+              <a:rPr sz="1000" b="1" i="0">
+                <a:solidFill>
+                  <a:srgbClr val="FFFFFF"/>
+                </a:solidFill>
+                <a:latin typeface="Calibri"/>
+              </a:rPr>
+              <a:t>▲ indexer · otomatik</a:t>
+            </a:r>
+          </a:p>
+        </p:txBody>
+      </p:sp>
       <p:cxnSp>
         <p:nvCxnSpPr>
-          <p:cNvPr id="25" name="Connector 24"/>
+          <p:cNvPr id="27" name="Connector 26"/>
           <p:cNvCxnSpPr/>
           <p:nvPr/>
         </p:nvCxnSpPr>
@@ -11354,7 +11423,7 @@
       </p:cxnSp>
       <p:cxnSp>
         <p:nvCxnSpPr>
-          <p:cNvPr id="26" name="Connector 25"/>
+          <p:cNvPr id="28" name="Connector 27"/>
           <p:cNvCxnSpPr/>
           <p:nvPr/>
         </p:nvCxnSpPr>
@@ -11390,7 +11459,7 @@
       </p:cxnSp>
       <p:sp>
         <p:nvSpPr>
-          <p:cNvPr id="27" name="Rounded Rectangle 26"/>
+          <p:cNvPr id="29" name="Rounded Rectangle 28"/>
           <p:cNvSpPr/>
           <p:nvPr/>
         </p:nvSpPr>
@@ -11420,7 +11489,7 @@
       </p:sp>
       <p:pic>
         <p:nvPicPr>
-          <p:cNvPr id="28" name="Picture 27" descr="github-g.png"/>
+          <p:cNvPr id="30" name="Picture 29" descr="github-g.png"/>
           <p:cNvPicPr>
             <a:picLocks noChangeAspect="1"/>
           </p:cNvPicPr>
@@ -11444,7 +11513,7 @@
       </p:pic>
       <p:sp>
         <p:nvSpPr>
-          <p:cNvPr id="29" name="TextBox 28"/>
+          <p:cNvPr id="31" name="TextBox 30"/>
           <p:cNvSpPr txBox="1"/>
           <p:nvPr/>
         </p:nvSpPr>
@@ -11510,7 +11579,7 @@
       </p:sp>
       <p:sp>
         <p:nvSpPr>
-          <p:cNvPr id="30" name="Rounded Rectangle 29"/>
+          <p:cNvPr id="32" name="Rounded Rectangle 31"/>
           <p:cNvSpPr/>
           <p:nvPr/>
         </p:nvSpPr>
@@ -11540,7 +11609,7 @@
       </p:sp>
       <p:sp>
         <p:nvSpPr>
-          <p:cNvPr id="31" name="TextBox 30"/>
+          <p:cNvPr id="33" name="TextBox 32"/>
           <p:cNvSpPr txBox="1"/>
           <p:nvPr/>
         </p:nvSpPr>
@@ -11659,7 +11728,7 @@
       </p:sp>
       <p:sp>
         <p:nvSpPr>
-          <p:cNvPr id="32" name="Rounded Rectangle 31"/>
+          <p:cNvPr id="34" name="Rounded Rectangle 33"/>
           <p:cNvSpPr/>
           <p:nvPr/>
         </p:nvSpPr>
@@ -11689,7 +11758,7 @@
       </p:sp>
       <p:sp>
         <p:nvSpPr>
-          <p:cNvPr id="33" name="TextBox 32"/>
+          <p:cNvPr id="35" name="TextBox 34"/>
           <p:cNvSpPr txBox="1"/>
           <p:nvPr/>
         </p:nvSpPr>

</xml_diff>

<commit_message>
Sunum: mimari (Foundry agent, 2 indeks, MI), senaryolar, canlı demo, iş değeri ve durum gerçek sisteme göre
Co-Authored-By: Claude Opus 5.5 <noreply@anthropic.com>
Claude-Session: https://claude.ai/code/session_01RS4uxdT3Pb9iyyB45qdRXr
</commit_message>
<xml_diff>
--- a/presentation/Mercek_AI_Overflow_Sunum.pptx
+++ b/presentation/Mercek_AI_Overflow_Sunum.pptx
@@ -609,7 +609,7 @@
           <a:lstStyle/>
           <a:p>
             <a:r>
-              <a:t>4:45–4:55 · 'Tamamlanan' listesini 2. gün 12:00'de gerçek duruma göre güncelleyin. S-C: AI yanlışsa → eşik, kaynak, sayı doğrulaması, insan onayı. Maliyet → küçük model, kısa bağlam, analiz başına ölçülen token.</a:t>
+              <a:t>4:45–4:55 · Tamamlanan: Modül 1 sohbeti dört araçla çalışıyor, Foundry agent ve izleme açık, L2 için KVKK'ya uygun müşteri listesi var, tüm bağlantılar parolasız. Sırada: modele gitmeden kişisel veri taraması, kurum e-postalarında kök neden araması ve Modül 2. Soru gelirse: AI yanlışsa → %75 eşik, kaynak, koddan rakam, insan onayı. Maliyet → tek agent, kısa bağlam, araç sonuçları özet.</a:t>
             </a:r>
           </a:p>
         </p:txBody>
@@ -1029,7 +1029,7 @@
           <a:lstStyle/>
           <a:p>
             <a:r>
-              <a:t>0:58–1:05 · Mercek hibrit RAG kullanır: AI Search geçmiş çözümleri, talepleri ve duyuruları anlam benzerliğiyle bulur (vektör + kelime, Türkçe analizör, Foundry embedding); Azure SQL o anki gerçek rakamları parametreli sorgularla getirir. SQL'e yazılan çözüm ve talepler AI Search indexer'ıyla birkaç dakikada kendiliğinden indekse girer; embedding'i Search, Foundry ile kendisi üretir. Foundry ikisini bağlam olarak alıp cevabı yazar; rakam uydurmaz çünkü her sayı SQL'den gelir. Model SQL yazmaz (text-to-SQL yok). CI/CD her PR'da test ve güvenlik taraması yapıyor. Sağda AI'ın ve kuralların işi. (Yalnızca gerçekten çalışan servisler bu slaytta kalmalı.)</a:t>
+              <a:t>0:58–1:05 · Mercek, Foundry Agent Service'te tanımlı mercek-cagri agent'ını kullanır. Agent dört araçtan hangisini çağıracağına karar verir: kibana_sorgula ve cagri_ara Azure SQL'deki log ve çağrı verisini, hata_ara ve benzer_cozum_ara AI Search'teki hata türü ve hazır çözüm indekslerini sorgular. Araçları backend çalıştırır; rakam, eşleşme yüzdesi (%75 eşik) ve yetki kodda. AI Search indeksleri SQL'den indexer ile 5 dakikada bir kendiliğinden güncellenir. Konuşma geçmişi ve KVKK erişim kaydı SQL'de; agent'ın her adımı Foundry'de App Insights ile izlenir. Tüm servis bağlantıları Managed Identity ile, parolasız.</a:t>
             </a:r>
           </a:p>
         </p:txBody>
@@ -1099,7 +1099,7 @@
           <a:lstStyle/>
           <a:p>
             <a:r>
-              <a:t>1:05–1:20 · Mercek'in altı kullanım senaryosu. 'CANLI' etiketliler birazdan canlı gösterilecek; diğerleri ekran görüntüsü veya kısa videoyla. (2. gün 12:00 kod dondurmada etiketleri gerçek duruma göre güncelleyin: canlı demoya yalnızca deploy edilmiş ortamda doğrulaması yeşil ve 3 provada hatasız olan senaryolar girer.)</a:t>
+              <a:t>1:05–1:20 · 'CANLI' etiketli beşi Mercek'te çalışıyor ve birazdan gösterilecek; 'PLAN' Modül 2 (talep analizi), sıradaki iş. A: KRDTKULL 120218, taksit gelirin %50'sini aşıyor; iş kuralı. B: Başkentgaz kurum zaman aşımı, SOL-031 ile kapanmış 6 çağrı, cevabın altında 'Akışı izle'. C: İSKİ 13 hane, 158 kayıt; geçmişte 'kullanıcı hatası' diye kapatılmış ama tek kurumda yoğunlaşıyor, Mercek temkinli. D: L2 için etkilenen müşteri listesi, KVKK'ya uygun. F: Kerem 'Son durum ne?' diye sorar.</a:t>
             </a:r>
           </a:p>
         </p:txBody>
@@ -1169,7 +1169,7 @@
           <a:lstStyle/>
           <a:p>
             <a:r>
-              <a:t>1:20–4:15 · CANLI DEMO (~3 dk), önce demo_reset çalıştırılmış olmalı. A: Elif KRDTKULL 400.000 / 3 ay → Sorun yaşıyorum → iş kuralı kartı → Bana göster. B: Mehmet ODMTFATR Başkentgaz (odm-dogalgaz turu) → Zeynep Mercek'e yazar → müşteriye söylenecek metin, CAG-2051 bağlı vaka 12 → Kerem %93 eşleşme. C: Elif İSKİ metni → 412 / %97 / 13 hane, duyuru → Kerem: %35, kod analizi, diff, ASKİ. D: Fatma talebi → analiz kartları → önerileri kabul et → 18 a/g, 9 Kasım–2 Aralık → köprü → Evet → 20 a/g, 4 Aralık. Canlıda olmayan sahneyi ekran görüntüsüyle 15 sn'de geçin; bir sahne bozulursa videosuna geçin.</a:t>
+              <a:t>1:20–4:15 · CANLI DEMO (~3 dk). B: Elif → 'ODMTTLMT ekranında hata alıyorum' → 7 hata, GAZ02 110731, SOL-031 (6 çağrı) → 'Akışı izle'ye tıklayın; aynı sohbette 'Peki nasıl çözerim?' (önceki konuyu hatırlar). C: Yeni sohbet → 'abone numarasını sistem kabul etmiyor' → AI Search hata türünü bulur, İSKİ 13 hane, SOL-005 temkinli. D: Kerem → K8 sorusu → 'Etkilenen müşteriler (31)' → tablo, 11 aranabilir, maskeli telefonlar. Güvenilir AI: Kerem → K5 → hazır çözüm yok. Sonra Foundry → Aracılar → mercek-cagri → İzlemeler: araç adımları. Yedek: sorun çıkarsa LLM_MODE=chat; ekran kaydına geçin.</a:t>
             </a:r>
           </a:p>
         </p:txBody>
@@ -1239,7 +1239,7 @@
           <a:lstStyle/>
           <a:p>
             <a:r>
-              <a:t>4:15–4:45 · Önce/sonra. Demo sırasında artan sayaçları ve ölçülen analiz süresini söyleyin. Varsayımları açıkça belirtin.</a:t>
+              <a:t>4:15–4:45 · Önce/sonra. Demodaki sayılarla bağlayın: 7 hata ve SOL-031 saniyeler içinde; İSKİ tarafında 158 kayıt tek kurumda; 31 etkilenen müşteri, 11 aranabilir. Veri sentetik.</a:t>
             </a:r>
           </a:p>
         </p:txBody>
@@ -5097,7 +5097,7 @@
                 </a:solidFill>
                 <a:latin typeface="Calibri"/>
               </a:rPr>
-              <a:t>M1: bağlam, log örüntüsü, servis ataması, ana kayıt, eşleştirme, kod analizi</a:t>
+              <a:t>M1 sohbet: log, çağrı, hata türü ve hazır çözüm araçları</a:t>
             </a:r>
           </a:p>
           <a:p>
@@ -5118,7 +5118,7 @@
                 </a:solidFill>
                 <a:latin typeface="Calibri"/>
               </a:rPr>
-              <a:t>M2: talep analizi, servis etkisi, adam-gün, takvim, köprü</a:t>
+              <a:t>Foundry agent (mercek-cagri) ve izleme</a:t>
             </a:r>
           </a:p>
           <a:p>
@@ -5139,7 +5139,7 @@
                 </a:solidFill>
                 <a:latin typeface="Calibri"/>
               </a:rPr>
-              <a:t>Azure: 2 App Service, Foundry, hibrit RAG (AI Search + SQL)</a:t>
+              <a:t>L2 etkilenen müşteri listesi, erişim kaydı</a:t>
             </a:r>
           </a:p>
           <a:p>
@@ -5160,7 +5160,7 @@
                 </a:solidFill>
                 <a:latin typeface="Calibri"/>
               </a:rPr>
-              <a:t>CI/CD ve PR'da güvenlik taraması</a:t>
+              <a:t>Azure: 2 App Service, SQL, AI Search, Managed Identity</a:t>
             </a:r>
           </a:p>
         </p:txBody>
@@ -5367,7 +5367,7 @@
                 </a:solidFill>
                 <a:latin typeface="Calibri"/>
               </a:rPr>
-              <a:t>Kod düzeltmeleri öneri; uygulama insan onaylı</a:t>
+              <a:t>Çözüm önerisi; karar insanda</a:t>
             </a:r>
           </a:p>
           <a:p>
@@ -5388,7 +5388,7 @@
                 </a:solidFill>
                 <a:latin typeface="Calibri"/>
               </a:rPr>
-              <a:t>E-posta ve SMS gönderimi simülasyon</a:t>
+              <a:t>Arama ve SMS yok, liste bilgilendirme için</a:t>
             </a:r>
           </a:p>
         </p:txBody>
@@ -5509,7 +5509,7 @@
                 </a:solidFill>
                 <a:latin typeface="Calibri"/>
               </a:rPr>
-              <a:t>Canlıya geçiş</a:t>
+              <a:t>Sırada</a:t>
             </a:r>
           </a:p>
         </p:txBody>
@@ -5553,7 +5553,7 @@
                 </a:solidFill>
                 <a:latin typeface="Calibri"/>
               </a:rPr>
-              <a:t>Log kaynağı: Kibana / Elasticsearch</a:t>
+              <a:t>KVKK: modele gitmeden metin taraması</a:t>
             </a:r>
           </a:p>
           <a:p>
@@ -5574,7 +5574,7 @@
                 </a:solidFill>
                 <a:latin typeface="Calibri"/>
               </a:rPr>
-              <a:t>Çağrı sistemi ve kod reposu için salt-okur entegrasyon</a:t>
+              <a:t>Duyuru ve işlenmemiş e-posta araması (İSKİ)</a:t>
             </a:r>
           </a:p>
           <a:p>
@@ -5595,7 +5595,7 @@
                 </a:solidFill>
                 <a:latin typeface="Calibri"/>
               </a:rPr>
-              <a:t>KVKK: loglarda maskeleme</a:t>
+              <a:t>Modül 2: talep analizi, efor, takvim</a:t>
             </a:r>
           </a:p>
           <a:p>
@@ -5616,7 +5616,7 @@
                 </a:solidFill>
                 <a:latin typeface="Calibri"/>
               </a:rPr>
-              <a:t>Pilot: şube kanalı, KRDTKULL ve ODMTFATR</a:t>
+              <a:t>Pilot: şube kanalı, ODMTTLMT ve KRDTKULL</a:t>
             </a:r>
           </a:p>
         </p:txBody>
@@ -9774,7 +9774,7 @@
                 </a:solidFill>
                 <a:latin typeface="Calibri"/>
               </a:rPr>
-              <a:t>Bugünkü araçlar sorunu kaydeder; Mercek açıklar, kaynağına bağlar ve yeni talebin planına taşır.</a:t>
+              <a:t>Bugünkü araçlar sorunu kaydeder; Mercek açıklar, kaynağına bağlar ve eyleme dönüştürür.</a:t>
             </a:r>
           </a:p>
         </p:txBody>
@@ -9950,7 +9950,7 @@
                 </a:solidFill>
                 <a:latin typeface="Calibri"/>
               </a:rPr>
-              <a:t>Ekran kodu, son işlemin logu ve temsilcinin cümlesiyle çalışır; kullanıcı yazmadan açıklar ve ekranı doğru değerlerle doldurur.</a:t>
+              <a:t>Kullanıcının görevini ve kendi logunu bilir; ekran adı söylenmese de belirtiden hatayı anlamca bulur.</a:t>
             </a:r>
           </a:p>
         </p:txBody>
@@ -10071,7 +10071,7 @@
                 </a:solidFill>
                 <a:latin typeface="Calibri"/>
               </a:rPr>
-              <a:t>Üç kaynağı birleştirir</a:t>
+              <a:t>Dört kaynağı birleştirir</a:t>
             </a:r>
           </a:p>
           <a:p>
@@ -10087,7 +10087,7 @@
                 </a:solidFill>
                 <a:latin typeface="Calibri"/>
               </a:rPr>
-              <a:t>Log (ne oluyor), kurum duyurusu (neden) ve uygulama kodu (nerede düzeltilir) tek analizde.</a:t>
+              <a:t>Log (ne oluyor), geçmiş çağrı (nasıl çözüldü), hata türü ve hazır çözüm araması tek cevapta.</a:t>
             </a:r>
           </a:p>
         </p:txBody>
@@ -10208,7 +10208,7 @@
                 </a:solidFill>
                 <a:latin typeface="Calibri"/>
               </a:rPr>
-              <a:t>Kapalı döngü</a:t>
+              <a:t>Sorundan eyleme</a:t>
             </a:r>
           </a:p>
           <a:p>
@@ -10224,7 +10224,7 @@
                 </a:solidFill>
                 <a:latin typeface="Calibri"/>
               </a:rPr>
-              <a:t>Çağrı ve müşteri verisi, talebin değerini kanıtlar ve eksik kapsamı talep anında gösterir.</a:t>
+              <a:t>Çözümün ekran akışını açar; L2 ekibine etkilenen müşteri listesini KVKK uyumlu verir.</a:t>
             </a:r>
           </a:p>
         </p:txBody>
@@ -10361,7 +10361,7 @@
                 </a:solidFill>
                 <a:latin typeface="Calibri"/>
               </a:rPr>
-              <a:t>Hesabı kod yapar, AI açıklar. Eşik altında öneri yok; her rakam ve kod satırı doğrulanır.</a:t>
+              <a:t>Hesabı kod yapar, AI açıklar. %75 eşiğin altında öneri yok; her rakam araçtan gelir.</a:t>
             </a:r>
           </a:p>
         </p:txBody>
@@ -10418,7 +10418,7 @@
                 </a:solidFill>
                 <a:latin typeface="Calibri"/>
               </a:rPr>
-              <a:t>Mimari: Azure Üzerinde Hibrit RAG</a:t>
+              <a:t>Mimari: Foundry Agent + Hibrit RAG</a:t>
             </a:r>
           </a:p>
         </p:txBody>
@@ -10605,11 +10605,9 @@
                 </a:solidFill>
                 <a:latin typeface="Calibri"/>
               </a:rPr>
-              <a:t>Şube, çağrı
-merkezi
-L2 destek
-İş birimi,
-analist</a:t>
+              <a:t>Şube
+Çağrı merkezi
+L2 destek</a:t>
             </a:r>
           </a:p>
         </p:txBody>
@@ -10695,8 +10693,8 @@
                 <a:latin typeface="Calibri"/>
               </a:rPr>
               <a:t>Next.js 16
-Bankacılık ekranları,
-Mercek, Talep</a:t>
+sohbet · Akışı izle
+L2 müşteri tablosu</a:t>
             </a:r>
           </a:p>
         </p:txBody>
@@ -10781,9 +10779,9 @@
                 </a:solidFill>
                 <a:latin typeface="Calibri"/>
               </a:rPr>
-              <a:t>FastAPI · /api/health
-orkestrasyon, hesap
-ve doğrulama</a:t>
+              <a:t>FastAPI · araçları çalıştırır
+hesap, eşik, yetki
+KVKK, erişim kaydı</a:t>
             </a:r>
           </a:p>
         </p:txBody>
@@ -10854,7 +10852,7 @@
                 </a:solidFill>
                 <a:latin typeface="Calibri"/>
               </a:rPr>
-              <a:t>HİBRİT RAG  </a:t>
+              <a:t>AGENT + HİBRİT RAG  </a:t>
             </a:r>
             <a:r>
               <a:rPr sz="1100" b="0" i="0">
@@ -10863,7 +10861,7 @@
                 </a:solidFill>
                 <a:latin typeface="Calibri"/>
               </a:rPr>
-              <a:t>1 getir · 2 bağlam · 3 üret</a:t>
+              <a:t>araç seçer · kod çalıştırır</a:t>
             </a:r>
           </a:p>
         </p:txBody>
@@ -10871,6 +10869,95 @@
       <p:sp>
         <p:nvSpPr>
           <p:cNvPr id="14" name="Rounded Rectangle 13"/>
+          <p:cNvSpPr/>
+          <p:nvPr/>
+        </p:nvSpPr>
+        <p:spPr>
+          <a:xfrm>
+            <a:off x="6903720" y="1554480"/>
+            <a:ext cx="1143000" cy="2926080"/>
+          </a:xfrm>
+          <a:prstGeom prst="roundRect">
+            <a:avLst>
+              <a:gd name="adj" fmla="val 6000"/>
+            </a:avLst>
+          </a:prstGeom>
+          <a:solidFill>
+            <a:srgbClr val="E10514"/>
+          </a:solidFill>
+          <a:ln>
+            <a:noFill/>
+          </a:ln>
+          <a:effectLst/>
+        </p:spPr>
+        <p:txBody>
+          <a:bodyPr rtlCol="0" anchor="ctr"/>
+          <a:lstStyle/>
+          <a:p/>
+        </p:txBody>
+      </p:sp>
+      <p:sp>
+        <p:nvSpPr>
+          <p:cNvPr id="15" name="TextBox 14"/>
+          <p:cNvSpPr txBox="1"/>
+          <p:nvPr/>
+        </p:nvSpPr>
+        <p:spPr>
+          <a:xfrm>
+            <a:off x="6976872" y="1600200"/>
+            <a:ext cx="996696" cy="2834640"/>
+          </a:xfrm>
+          <a:prstGeom prst="rect">
+            <a:avLst/>
+          </a:prstGeom>
+          <a:noFill/>
+        </p:spPr>
+        <p:txBody>
+          <a:bodyPr wrap="square" anchor="ctr" lIns="0" rIns="0" tIns="0" bIns="0">
+            <a:spAutoFit/>
+          </a:bodyPr>
+          <a:lstStyle/>
+          <a:p>
+            <a:pPr algn="ctr">
+              <a:spcAft>
+                <a:spcPts val="200"/>
+              </a:spcAft>
+            </a:pPr>
+            <a:r>
+              <a:rPr sz="1300" b="1" i="0">
+                <a:solidFill>
+                  <a:srgbClr val="FFFFFF"/>
+                </a:solidFill>
+                <a:latin typeface="Calibri"/>
+              </a:rPr>
+              <a:t>Foundry Agent</a:t>
+            </a:r>
+          </a:p>
+          <a:p>
+            <a:pPr algn="ctr">
+              <a:spcAft>
+                <a:spcPts val="200"/>
+              </a:spcAft>
+            </a:pPr>
+            <a:r>
+              <a:rPr sz="1100" b="0" i="0">
+                <a:solidFill>
+                  <a:srgbClr val="FFFFFF"/>
+                </a:solidFill>
+                <a:latin typeface="Calibri"/>
+              </a:rPr>
+              <a:t>mercek-cagri
+gpt-5.5
+4 araç
+izleme:
+App Insights</a:t>
+            </a:r>
+          </a:p>
+        </p:txBody>
+      </p:sp>
+      <p:sp>
+        <p:nvSpPr>
+          <p:cNvPr id="16" name="Rounded Rectangle 15"/>
           <p:cNvSpPr/>
           <p:nvPr/>
         </p:nvSpPr>
@@ -10902,7 +10989,7 @@
       </p:sp>
       <p:sp>
         <p:nvSpPr>
-          <p:cNvPr id="15" name="TextBox 14"/>
+          <p:cNvPr id="17" name="TextBox 16"/>
           <p:cNvSpPr txBox="1"/>
           <p:nvPr/>
         </p:nvSpPr>
@@ -10950,16 +11037,16 @@
                 </a:solidFill>
                 <a:latin typeface="Calibri"/>
               </a:rPr>
-              <a:t>1 · anlamca getir
-çözüm · talep · duyuru
-vektör + kelime, Türkçe</a:t>
-            </a:r>
-          </a:p>
-        </p:txBody>
-      </p:sp>
-      <p:sp>
-        <p:nvSpPr>
-          <p:cNvPr id="16" name="Rounded Rectangle 15"/>
+              <a:t>hata türleri (107)
+hazır çözüm + çağrı
+notu (37) · %75 eşik</a:t>
+            </a:r>
+          </a:p>
+        </p:txBody>
+      </p:sp>
+      <p:sp>
+        <p:nvSpPr>
+          <p:cNvPr id="18" name="Rounded Rectangle 17"/>
           <p:cNvSpPr/>
           <p:nvPr/>
         </p:nvSpPr>
@@ -10991,7 +11078,7 @@
       </p:sp>
       <p:sp>
         <p:nvSpPr>
-          <p:cNvPr id="17" name="TextBox 16"/>
+          <p:cNvPr id="19" name="TextBox 18"/>
           <p:cNvSpPr txBox="1"/>
           <p:nvPr/>
         </p:nvSpPr>
@@ -11039,53 +11126,23 @@
                 </a:solidFill>
                 <a:latin typeface="Calibri"/>
               </a:rPr>
-              <a:t>1 · rakamı getir
-log · çağrı · portföy · takvim
-parametreli sorgu</a:t>
-            </a:r>
-          </a:p>
-        </p:txBody>
-      </p:sp>
-      <p:sp>
-        <p:nvSpPr>
-          <p:cNvPr id="18" name="Rounded Rectangle 17"/>
-          <p:cNvSpPr/>
-          <p:nvPr/>
-        </p:nvSpPr>
-        <p:spPr>
-          <a:xfrm>
-            <a:off x="6903720" y="1554480"/>
-            <a:ext cx="1143000" cy="2926080"/>
-          </a:xfrm>
-          <a:prstGeom prst="roundRect">
-            <a:avLst>
-              <a:gd name="adj" fmla="val 6000"/>
-            </a:avLst>
-          </a:prstGeom>
-          <a:solidFill>
-            <a:srgbClr val="E10514"/>
-          </a:solidFill>
-          <a:ln>
-            <a:noFill/>
-          </a:ln>
-          <a:effectLst/>
-        </p:spPr>
-        <p:txBody>
-          <a:bodyPr rtlCol="0" anchor="ctr"/>
-          <a:lstStyle/>
-          <a:p/>
-        </p:txBody>
-      </p:sp>
-      <p:sp>
-        <p:nvSpPr>
-          <p:cNvPr id="19" name="TextBox 18"/>
+              <a:t>log · çağrı · müşteri
+konuşma geçmişi
+erişim kaydı</a:t>
+            </a:r>
+          </a:p>
+        </p:txBody>
+      </p:sp>
+      <p:sp>
+        <p:nvSpPr>
+          <p:cNvPr id="20" name="TextBox 19"/>
           <p:cNvSpPr txBox="1"/>
           <p:nvPr/>
         </p:nvSpPr>
         <p:spPr>
           <a:xfrm>
-            <a:off x="6976872" y="1600200"/>
-            <a:ext cx="996696" cy="2834640"/>
+            <a:off x="4572000" y="4572000"/>
+            <a:ext cx="3474720" cy="822960"/>
           </a:xfrm>
           <a:prstGeom prst="rect">
             <a:avLst/>
@@ -11098,76 +11155,19 @@
           </a:bodyPr>
           <a:lstStyle/>
           <a:p>
-            <a:pPr algn="ctr">
-              <a:spcAft>
-                <a:spcPts val="200"/>
-              </a:spcAft>
-            </a:pPr>
-            <a:r>
-              <a:rPr sz="1300" b="1" i="0">
-                <a:solidFill>
-                  <a:srgbClr val="FFFFFF"/>
-                </a:solidFill>
-                <a:latin typeface="Calibri"/>
-              </a:rPr>
-              <a:t>Azure AI Foundry</a:t>
-            </a:r>
-          </a:p>
-          <a:p>
-            <a:pPr algn="ctr">
-              <a:spcAft>
-                <a:spcPts val="200"/>
+            <a:pPr algn="l">
+              <a:spcAft>
+                <a:spcPts val="400"/>
               </a:spcAft>
             </a:pPr>
             <a:r>
               <a:rPr sz="1100" b="0" i="0">
                 <a:solidFill>
-                  <a:srgbClr val="FFFFFF"/>
-                </a:solidFill>
-                <a:latin typeface="Calibri"/>
-              </a:rPr>
-              <a:t>2 · bağlam
-3 · chat ile üret
-embedding → indeks</a:t>
-            </a:r>
-          </a:p>
-        </p:txBody>
-      </p:sp>
-      <p:sp>
-        <p:nvSpPr>
-          <p:cNvPr id="20" name="TextBox 19"/>
-          <p:cNvSpPr txBox="1"/>
-          <p:nvPr/>
-        </p:nvSpPr>
-        <p:spPr>
-          <a:xfrm>
-            <a:off x="4572000" y="4572000"/>
-            <a:ext cx="3474720" cy="822960"/>
-          </a:xfrm>
-          <a:prstGeom prst="rect">
-            <a:avLst/>
-          </a:prstGeom>
-          <a:noFill/>
-        </p:spPr>
-        <p:txBody>
-          <a:bodyPr wrap="square" anchor="ctr" lIns="0" rIns="0" tIns="0" bIns="0">
-            <a:spAutoFit/>
-          </a:bodyPr>
-          <a:lstStyle/>
-          <a:p>
-            <a:pPr algn="l">
-              <a:spcAft>
-                <a:spcPts val="400"/>
-              </a:spcAft>
-            </a:pPr>
-            <a:r>
-              <a:rPr sz="1100" b="0" i="0">
-                <a:solidFill>
                   <a:srgbClr val="1E1E1E"/>
                 </a:solidFill>
                 <a:latin typeface="Calibri"/>
               </a:rPr>
-              <a:t>Benzeri AI Search bulur, rakamı SQL verir; model yalnızca bu kaynaklı bağlamla yazar ve her cevapta kaynak no'su gösterir.</a:t>
+              <a:t>Agent hangi aracı çağıracağına karar verir; sorguyu backend çalıştırır. Rakam ve eşik koddan gelir, model yalnızca açıklar.</a:t>
             </a:r>
           </a:p>
         </p:txBody>
@@ -11380,86 +11380,14 @@
                 </a:solidFill>
                 <a:latin typeface="Calibri"/>
               </a:rPr>
-              <a:t>▲ indexer · otomatik</a:t>
-            </a:r>
-          </a:p>
-        </p:txBody>
-      </p:sp>
-      <p:cxnSp>
-        <p:nvCxnSpPr>
-          <p:cNvPr id="27" name="Connector 26"/>
-          <p:cNvCxnSpPr/>
-          <p:nvPr/>
-        </p:nvCxnSpPr>
-        <p:spPr>
-          <a:xfrm>
-            <a:off x="6675120" y="2286000"/>
-            <a:ext cx="228600" cy="365760"/>
-          </a:xfrm>
-          <a:prstGeom prst="line">
-            <a:avLst/>
-          </a:prstGeom>
-          <a:ln w="22225">
-            <a:solidFill>
-              <a:srgbClr val="E10514"/>
-            </a:solidFill>
-            <a:tailEnd type="triangle"/>
-          </a:ln>
-        </p:spPr>
-        <p:style>
-          <a:lnRef idx="2">
-            <a:schemeClr val="accent1"/>
-          </a:lnRef>
-          <a:fillRef idx="0">
-            <a:schemeClr val="accent1"/>
-          </a:fillRef>
-          <a:effectRef idx="1">
-            <a:schemeClr val="accent1"/>
-          </a:effectRef>
-          <a:fontRef idx="minor">
-            <a:schemeClr val="tx1"/>
-          </a:fontRef>
-        </p:style>
-      </p:cxnSp>
-      <p:cxnSp>
-        <p:nvCxnSpPr>
-          <p:cNvPr id="28" name="Connector 27"/>
-          <p:cNvCxnSpPr/>
-          <p:nvPr/>
-        </p:nvCxnSpPr>
-        <p:spPr>
-          <a:xfrm flipV="1">
-            <a:off x="6675120" y="3383280"/>
-            <a:ext cx="228600" cy="429768"/>
-          </a:xfrm>
-          <a:prstGeom prst="line">
-            <a:avLst/>
-          </a:prstGeom>
-          <a:ln w="22225">
-            <a:solidFill>
-              <a:srgbClr val="E10514"/>
-            </a:solidFill>
-            <a:tailEnd type="triangle"/>
-          </a:ln>
-        </p:spPr>
-        <p:style>
-          <a:lnRef idx="2">
-            <a:schemeClr val="accent1"/>
-          </a:lnRef>
-          <a:fillRef idx="0">
-            <a:schemeClr val="accent1"/>
-          </a:fillRef>
-          <a:effectRef idx="1">
-            <a:schemeClr val="accent1"/>
-          </a:effectRef>
-          <a:fontRef idx="minor">
-            <a:schemeClr val="tx1"/>
-          </a:fontRef>
-        </p:style>
-      </p:cxnSp>
-      <p:sp>
-        <p:nvSpPr>
-          <p:cNvPr id="29" name="Rounded Rectangle 28"/>
+              <a:t>▲ indexer · 5 dk</a:t>
+            </a:r>
+          </a:p>
+        </p:txBody>
+      </p:sp>
+      <p:sp>
+        <p:nvSpPr>
+          <p:cNvPr id="27" name="Rounded Rectangle 26"/>
           <p:cNvSpPr/>
           <p:nvPr/>
         </p:nvSpPr>
@@ -11489,7 +11417,7 @@
       </p:sp>
       <p:pic>
         <p:nvPicPr>
-          <p:cNvPr id="30" name="Picture 29" descr="github-g.png"/>
+          <p:cNvPr id="28" name="Picture 27" descr="shield-g.png"/>
           <p:cNvPicPr>
             <a:picLocks noChangeAspect="1"/>
           </p:cNvPicPr>
@@ -11513,7 +11441,7 @@
       </p:pic>
       <p:sp>
         <p:nvSpPr>
-          <p:cNvPr id="31" name="TextBox 30"/>
+          <p:cNvPr id="29" name="TextBox 28"/>
           <p:cNvSpPr txBox="1"/>
           <p:nvPr/>
         </p:nvSpPr>
@@ -11545,7 +11473,7 @@
                 </a:solidFill>
                 <a:latin typeface="Calibri"/>
               </a:rPr>
-              <a:t>GitHub Actions: </a:t>
+              <a:t>Parolasız: </a:t>
             </a:r>
             <a:r>
               <a:rPr sz="1200" b="0" i="0">
@@ -11554,7 +11482,7 @@
                 </a:solidFill>
                 <a:latin typeface="Calibri"/>
               </a:rPr>
-              <a:t>lint · test · audit · gitleaks → build → 2 deploy → smoke test    </a:t>
+              <a:t>Managed Identity ile SQL, AI Search ve Foundry    </a:t>
             </a:r>
             <a:r>
               <a:rPr sz="1200" b="1" i="0">
@@ -11579,7 +11507,7 @@
       </p:sp>
       <p:sp>
         <p:nvSpPr>
-          <p:cNvPr id="32" name="Rounded Rectangle 31"/>
+          <p:cNvPr id="30" name="Rounded Rectangle 29"/>
           <p:cNvSpPr/>
           <p:nvPr/>
         </p:nvSpPr>
@@ -11609,7 +11537,7 @@
       </p:sp>
       <p:sp>
         <p:nvSpPr>
-          <p:cNvPr id="33" name="TextBox 32"/>
+          <p:cNvPr id="31" name="TextBox 30"/>
           <p:cNvSpPr txBox="1"/>
           <p:nvPr/>
         </p:nvSpPr>
@@ -11657,7 +11585,7 @@
                 </a:solidFill>
                 <a:latin typeface="Calibri"/>
               </a:rPr>
-              <a:t>Metinden bilgi çıkarma, açıklama</a:t>
+              <a:t>Belirtiyi anlar, ekranı bulur</a:t>
             </a:r>
           </a:p>
           <a:p>
@@ -11673,7 +11601,7 @@
                 </a:solidFill>
                 <a:latin typeface="Calibri"/>
               </a:rPr>
-              <a:t>Çağrı zenginleştirme</a:t>
+              <a:t>Hangi aracı çağıracağına karar verir</a:t>
             </a:r>
           </a:p>
           <a:p>
@@ -11689,7 +11617,7 @@
                 </a:solidFill>
                 <a:latin typeface="Calibri"/>
               </a:rPr>
-              <a:t>Çözüm uyarlama</a:t>
+              <a:t>Hazır çözümü kullanıcıya uyarlar</a:t>
             </a:r>
           </a:p>
           <a:p>
@@ -11705,30 +11633,14 @@
                 </a:solidFill>
                 <a:latin typeface="Calibri"/>
               </a:rPr>
-              <a:t>Kod analizi</a:t>
-            </a:r>
-          </a:p>
-          <a:p>
-            <a:pPr algn="l">
-              <a:spcAft>
-                <a:spcPts val="300"/>
-              </a:spcAft>
-            </a:pPr>
-            <a:r>
-              <a:rPr sz="1400" b="0" i="0">
-                <a:solidFill>
-                  <a:srgbClr val="FFFFFF"/>
-                </a:solidFill>
-                <a:latin typeface="Calibri"/>
-              </a:rPr>
-              <a:t>Talep bileşenleri ve sorular</a:t>
-            </a:r>
-          </a:p>
-        </p:txBody>
-      </p:sp>
-      <p:sp>
-        <p:nvSpPr>
-          <p:cNvPr id="34" name="Rounded Rectangle 33"/>
+              <a:t>Sistemsel riski açıklar</a:t>
+            </a:r>
+          </a:p>
+        </p:txBody>
+      </p:sp>
+      <p:sp>
+        <p:nvSpPr>
+          <p:cNvPr id="32" name="Rounded Rectangle 31"/>
           <p:cNvSpPr/>
           <p:nvPr/>
         </p:nvSpPr>
@@ -11758,7 +11670,7 @@
       </p:sp>
       <p:sp>
         <p:nvSpPr>
-          <p:cNvPr id="35" name="TextBox 34"/>
+          <p:cNvPr id="33" name="TextBox 32"/>
           <p:cNvSpPr txBox="1"/>
           <p:nvPr/>
         </p:nvSpPr>
@@ -11806,7 +11718,7 @@
                 </a:solidFill>
                 <a:latin typeface="Calibri"/>
               </a:rPr>
-              <a:t>Log örüntüsü, kredi hesabı</a:t>
+              <a:t>Log sayımı, zaman aralığı</a:t>
             </a:r>
           </a:p>
           <a:p>
@@ -11822,7 +11734,7 @@
                 </a:solidFill>
                 <a:latin typeface="Calibri"/>
               </a:rPr>
-              <a:t>Eşik, servis ataması, ana kayıt</a:t>
+              <a:t>Eşleşme yüzdesi, %75 eşik</a:t>
             </a:r>
           </a:p>
           <a:p>
@@ -11838,7 +11750,7 @@
                 </a:solidFill>
                 <a:latin typeface="Calibri"/>
               </a:rPr>
-              <a:t>Adam-gün medyanı, takvim</a:t>
+              <a:t>L2 yetkisi, telefon maskesi</a:t>
             </a:r>
           </a:p>
           <a:p>
@@ -11854,7 +11766,7 @@
                 </a:solidFill>
                 <a:latin typeface="Calibri"/>
               </a:rPr>
-              <a:t>Köprü sayıları</a:t>
+              <a:t>Akış bağlantısı seçimi</a:t>
             </a:r>
           </a:p>
           <a:p>
@@ -11870,7 +11782,7 @@
                 </a:solidFill>
                 <a:latin typeface="Calibri"/>
               </a:rPr>
-              <a:t>AI çıktısındaki sayı ve satırları doğrulama</a:t>
+              <a:t>Erişim kaydı (audit)</a:t>
             </a:r>
           </a:p>
         </p:txBody>
@@ -12220,7 +12132,7 @@
                 </a:solidFill>
                 <a:latin typeface="Calibri"/>
               </a:rPr>
-              <a:t>İş kuralı açıklandı, uygun tutar ekrana dolduruldu</a:t>
+              <a:t>Taksit gelirin %50'sini aşıyor: iş kuralı açıklanır</a:t>
             </a:r>
           </a:p>
         </p:txBody>
@@ -12259,7 +12171,7 @@
                 </a:solidFill>
                 <a:latin typeface="Calibri"/>
               </a:rPr>
-              <a:t>Çağrı açılmadı</a:t>
+              <a:t>Çağrı açılmadan çözülür</a:t>
             </a:r>
           </a:p>
         </p:txBody>
@@ -12480,7 +12392,7 @@
                 </a:solidFill>
                 <a:latin typeface="Calibri"/>
               </a:rPr>
-              <a:t>ODMTFATR · Mehmet → Zeynep → Kerem</a:t>
+              <a:t>ODMTTLMT · GAZ02 · Elif, Zeynep, Kerem</a:t>
             </a:r>
           </a:p>
         </p:txBody>
@@ -12519,7 +12431,7 @@
                 </a:solidFill>
                 <a:latin typeface="Calibri"/>
               </a:rPr>
-              <a:t>Müşteriye hazır açıklama, %93 eşleşen çözüm</a:t>
+              <a:t>Kurum zaman aşımı, SOL-031 ve adım adım akış</a:t>
             </a:r>
           </a:p>
         </p:txBody>
@@ -12558,7 +12470,7 @@
                 </a:solidFill>
                 <a:latin typeface="Calibri"/>
               </a:rPr>
-              <a:t>Onlarca arama tek kayıtta</a:t>
+              <a:t>6 benzer çağrı · 23 kayıt</a:t>
             </a:r>
           </a:p>
         </p:txBody>
@@ -12763,7 +12675,7 @@
                 </a:solidFill>
                 <a:latin typeface="Calibri"/>
               </a:rPr>
-              <a:t>Dış dünya değişti</a:t>
+              <a:t>Kural yanlış kapatılmış</a:t>
             </a:r>
           </a:p>
           <a:p>
@@ -12779,7 +12691,7 @@
                 </a:solidFill>
                 <a:latin typeface="Calibri"/>
               </a:rPr>
-              <a:t>ODMTFATR · Elif → Kerem</a:t>
+              <a:t>ODMTTLMT · İSKİ 13 hane · Elif → Kerem</a:t>
             </a:r>
           </a:p>
         </p:txBody>
@@ -12818,7 +12730,7 @@
                 </a:solidFill>
                 <a:latin typeface="Calibri"/>
               </a:rPr>
-              <a:t>Log + kurum duyurusu + kod; düzeltme önerisi</a:t>
+              <a:t>158 kayıt, tek kurumda; 'kullanıcı hatası' temkinli</a:t>
             </a:r>
           </a:p>
         </p:txBody>
@@ -12857,7 +12769,7 @@
                 </a:solidFill>
                 <a:latin typeface="Calibri"/>
               </a:rPr>
-              <a:t>187 müşteri · ASKİ önceden</a:t>
+              <a:t>Sistemsel olabilir uyarısı</a:t>
             </a:r>
           </a:p>
         </p:txBody>
@@ -13062,7 +12974,7 @@
                 </a:solidFill>
                 <a:latin typeface="Calibri"/>
               </a:rPr>
-              <a:t>Talepten plana</a:t>
+              <a:t>Etkilenen müşteriler</a:t>
             </a:r>
           </a:p>
           <a:p>
@@ -13078,7 +12990,7 @@
                 </a:solidFill>
                 <a:latin typeface="Calibri"/>
               </a:rPr>
-              <a:t>Talep Yönlendirme · Fatma → Ayşe</a:t>
+              <a:t>Fatura talimatı · Kerem (L2)</a:t>
             </a:r>
           </a:p>
         </p:txBody>
@@ -13117,7 +13029,7 @@
                 </a:solidFill>
                 <a:latin typeface="Calibri"/>
               </a:rPr>
-              <a:t>Servis, adam-gün, takvim; veriyle kapsam</a:t>
+              <a:t>Bilgilendirme listesi; izinsiz telefon maskeli</a:t>
             </a:r>
           </a:p>
         </p:txBody>
@@ -13156,7 +13068,7 @@
                 </a:solidFill>
                 <a:latin typeface="Calibri"/>
               </a:rPr>
-              <a:t>Erişim %58 → %89 · 20 a/g</a:t>
+              <a:t>31 müşteri · 11 aranabilir</a:t>
             </a:r>
           </a:p>
         </p:txBody>
@@ -13361,7 +13273,7 @@
                 </a:solidFill>
                 <a:latin typeface="Calibri"/>
               </a:rPr>
-              <a:t>Acil yeni ekran</a:t>
+              <a:t>Talepten plana</a:t>
             </a:r>
           </a:p>
           <a:p>
@@ -13377,7 +13289,7 @@
                 </a:solidFill>
                 <a:latin typeface="Calibri"/>
               </a:rPr>
-              <a:t>KRDTERTL (yeni) · Hakan → Ayşe</a:t>
+              <a:t>Talep analizi · Fatma → Ayşe</a:t>
             </a:r>
           </a:p>
         </p:txBody>
@@ -13416,7 +13328,7 @@
                 </a:solidFill>
                 <a:latin typeface="Calibri"/>
               </a:rPr>
-              <a:t>Etkilenen müşteri, riskli sorular, kapasite çatışması</a:t>
+              <a:t>Servis, adam-gün, takvim; veriyle kapsam</a:t>
             </a:r>
           </a:p>
         </p:txBody>
@@ -13455,7 +13367,7 @@
                 </a:solidFill>
                 <a:latin typeface="Calibri"/>
               </a:rPr>
-              <a:t>Aynı gün karar · 17 a/g</a:t>
+              <a:t>Modül 2 · sırada</a:t>
             </a:r>
           </a:p>
         </p:txBody>
@@ -13524,7 +13436,7 @@
                 </a:solidFill>
                 <a:latin typeface="Calibri"/>
               </a:rPr>
-              <a:t>KAYIT</a:t>
+              <a:t>PLAN</a:t>
             </a:r>
           </a:p>
         </p:txBody>
@@ -13574,7 +13486,7 @@
             <a:avLst/>
           </a:prstGeom>
           <a:solidFill>
-            <a:srgbClr val="91969B"/>
+            <a:srgbClr val="E10514"/>
           </a:solidFill>
           <a:ln>
             <a:noFill/>
@@ -13750,11 +13662,11 @@
             <a:r>
               <a:rPr sz="1400" b="1" i="0">
                 <a:solidFill>
-                  <a:srgbClr val="1E1E1E"/>
-                </a:solidFill>
-                <a:latin typeface="Calibri"/>
-              </a:rPr>
-              <a:t>En sorunlu ekran: ODMTFATR</a:t>
+                  <a:srgbClr val="B90F0A"/>
+                </a:solidFill>
+                <a:latin typeface="Calibri"/>
+              </a:rPr>
+              <a:t>Son 30 dk: 23 hata</a:t>
             </a:r>
           </a:p>
         </p:txBody>
@@ -13776,7 +13688,7 @@
             </a:avLst>
           </a:prstGeom>
           <a:solidFill>
-            <a:srgbClr val="91969B"/>
+            <a:srgbClr val="E10514"/>
           </a:solidFill>
           <a:ln>
             <a:noFill/>
@@ -13823,7 +13735,7 @@
                 </a:solidFill>
                 <a:latin typeface="Calibri"/>
               </a:rPr>
-              <a:t>KAYIT</a:t>
+              <a:t>CANLI</a:t>
             </a:r>
           </a:p>
         </p:txBody>
@@ -13956,8 +13868,8 @@
         </p:nvSpPr>
         <p:spPr>
           <a:xfrm>
-            <a:off x="11292840" y="6382512"/>
-            <a:ext cx="685800" cy="274320"/>
+            <a:off x="155448" y="658368"/>
+            <a:ext cx="11430000" cy="365760"/>
           </a:xfrm>
           <a:prstGeom prst="rect">
             <a:avLst/>
@@ -13970,6 +13882,45 @@
           </a:bodyPr>
           <a:lstStyle/>
           <a:p>
+            <a:pPr algn="l">
+              <a:spcAft>
+                <a:spcPts val="400"/>
+              </a:spcAft>
+            </a:pPr>
+            <a:r>
+              <a:rPr sz="1600" b="0" i="0">
+                <a:solidFill>
+                  <a:srgbClr val="91969B"/>
+                </a:solidFill>
+                <a:latin typeface="Calibri"/>
+              </a:rPr>
+              <a:t>Her cevapta araç adımları Foundry izlemesinde görünür; rakamlar koddan gelir.</a:t>
+            </a:r>
+          </a:p>
+        </p:txBody>
+      </p:sp>
+      <p:sp>
+        <p:nvSpPr>
+          <p:cNvPr id="6" name="TextBox 5"/>
+          <p:cNvSpPr txBox="1"/>
+          <p:nvPr/>
+        </p:nvSpPr>
+        <p:spPr>
+          <a:xfrm>
+            <a:off x="11292840" y="6382512"/>
+            <a:ext cx="685800" cy="274320"/>
+          </a:xfrm>
+          <a:prstGeom prst="rect">
+            <a:avLst/>
+          </a:prstGeom>
+          <a:noFill/>
+        </p:spPr>
+        <p:txBody>
+          <a:bodyPr wrap="square" anchor="t" lIns="0" rIns="0" tIns="0" bIns="0">
+            <a:spAutoFit/>
+          </a:bodyPr>
+          <a:lstStyle/>
+          <a:p>
             <a:pPr algn="r">
               <a:spcAft>
                 <a:spcPts val="400"/>
@@ -13989,14 +13940,14 @@
       </p:sp>
       <p:sp>
         <p:nvSpPr>
-          <p:cNvPr id="6" name="Rounded Rectangle 5"/>
+          <p:cNvPr id="7" name="Rounded Rectangle 6"/>
           <p:cNvSpPr/>
           <p:nvPr/>
         </p:nvSpPr>
         <p:spPr>
           <a:xfrm>
-            <a:off x="411480" y="1051560"/>
-            <a:ext cx="5577840" cy="2377440"/>
+            <a:off x="411480" y="1188720"/>
+            <a:ext cx="5577840" cy="2331720"/>
           </a:xfrm>
           <a:prstGeom prst="roundRect">
             <a:avLst>
@@ -14017,9 +13968,37 @@
           <a:p/>
         </p:txBody>
       </p:sp>
+      <p:sp>
+        <p:nvSpPr>
+          <p:cNvPr id="8" name="Oval 7"/>
+          <p:cNvSpPr/>
+          <p:nvPr/>
+        </p:nvSpPr>
+        <p:spPr>
+          <a:xfrm>
+            <a:off x="640080" y="1417320"/>
+            <a:ext cx="685800" cy="685800"/>
+          </a:xfrm>
+          <a:prstGeom prst="ellipse">
+            <a:avLst/>
+          </a:prstGeom>
+          <a:solidFill>
+            <a:srgbClr val="E10514"/>
+          </a:solidFill>
+          <a:ln>
+            <a:noFill/>
+          </a:ln>
+          <a:effectLst/>
+        </p:spPr>
+        <p:txBody>
+          <a:bodyPr rtlCol="0" anchor="ctr"/>
+          <a:lstStyle/>
+          <a:p/>
+        </p:txBody>
+      </p:sp>
       <p:pic>
         <p:nvPicPr>
-          <p:cNvPr id="7" name="Picture 6" descr="m-a-panel.png"/>
+          <p:cNvPr id="9" name="Picture 8" descr="headset-w.png"/>
           <p:cNvPicPr>
             <a:picLocks noChangeAspect="1"/>
           </p:cNvPicPr>
@@ -14033,28 +14012,78 @@
         </p:blipFill>
         <p:spPr>
           <a:xfrm>
-            <a:off x="594360" y="1234439"/>
-            <a:ext cx="3397032" cy="2011680"/>
-          </a:xfrm>
-          <a:prstGeom prst="rect">
-            <a:avLst/>
-          </a:prstGeom>
-          <a:ln>
-            <a:solidFill>
-              <a:srgbClr val="B4BEC3"/>
-            </a:solidFill>
-          </a:ln>
+            <a:off x="811530" y="1588770"/>
+            <a:ext cx="342900" cy="342900"/>
+          </a:xfrm>
+          <a:prstGeom prst="rect">
+            <a:avLst/>
+          </a:prstGeom>
         </p:spPr>
       </p:pic>
       <p:sp>
         <p:nvSpPr>
-          <p:cNvPr id="8" name="Rounded Rectangle 7"/>
+          <p:cNvPr id="10" name="TextBox 9"/>
+          <p:cNvSpPr txBox="1"/>
+          <p:nvPr/>
+        </p:nvSpPr>
+        <p:spPr>
+          <a:xfrm>
+            <a:off x="1508760" y="1389888"/>
+            <a:ext cx="3291839" cy="731520"/>
+          </a:xfrm>
+          <a:prstGeom prst="rect">
+            <a:avLst/>
+          </a:prstGeom>
+          <a:noFill/>
+        </p:spPr>
+        <p:txBody>
+          <a:bodyPr wrap="square" anchor="ctr" lIns="0" rIns="0" tIns="0" bIns="0">
+            <a:spAutoFit/>
+          </a:bodyPr>
+          <a:lstStyle/>
+          <a:p>
+            <a:pPr algn="l">
+              <a:spcAft>
+                <a:spcPts val="100"/>
+              </a:spcAft>
+            </a:pPr>
+            <a:r>
+              <a:rPr sz="1800" b="1" i="0">
+                <a:solidFill>
+                  <a:srgbClr val="1E1E1E"/>
+                </a:solidFill>
+                <a:latin typeface="Calibri"/>
+              </a:rPr>
+              <a:t>B · Bilinen çözüm</a:t>
+            </a:r>
+          </a:p>
+          <a:p>
+            <a:pPr algn="l">
+              <a:spcAft>
+                <a:spcPts val="100"/>
+              </a:spcAft>
+            </a:pPr>
+            <a:r>
+              <a:rPr sz="1200" b="0" i="0">
+                <a:solidFill>
+                  <a:srgbClr val="91969B"/>
+                </a:solidFill>
+                <a:latin typeface="Calibri"/>
+              </a:rPr>
+              <a:t>Elif</a:t>
+            </a:r>
+          </a:p>
+        </p:txBody>
+      </p:sp>
+      <p:sp>
+        <p:nvSpPr>
+          <p:cNvPr id="11" name="Rounded Rectangle 10"/>
           <p:cNvSpPr/>
           <p:nvPr/>
         </p:nvSpPr>
         <p:spPr>
           <a:xfrm>
-            <a:off x="4174272" y="1234439"/>
+            <a:off x="4892040" y="1481328"/>
             <a:ext cx="868680" cy="310896"/>
           </a:xfrm>
           <a:prstGeom prst="roundRect">
@@ -14078,13 +14107,13 @@
       </p:sp>
       <p:sp>
         <p:nvSpPr>
-          <p:cNvPr id="9" name="TextBox 8"/>
+          <p:cNvPr id="12" name="TextBox 11"/>
           <p:cNvSpPr txBox="1"/>
           <p:nvPr/>
         </p:nvSpPr>
         <p:spPr>
           <a:xfrm>
-            <a:off x="4174272" y="1234439"/>
+            <a:off x="4892040" y="1481328"/>
             <a:ext cx="868680" cy="310896"/>
           </a:xfrm>
           <a:prstGeom prst="rect">
@@ -14117,14 +14146,14 @@
       </p:sp>
       <p:sp>
         <p:nvSpPr>
-          <p:cNvPr id="10" name="TextBox 9"/>
+          <p:cNvPr id="13" name="TextBox 12"/>
           <p:cNvSpPr txBox="1"/>
           <p:nvPr/>
         </p:nvSpPr>
         <p:spPr>
           <a:xfrm>
-            <a:off x="4174272" y="1645919"/>
-            <a:ext cx="1632167" cy="502920"/>
+            <a:off x="685800" y="2240280"/>
+            <a:ext cx="5029200" cy="1234440"/>
           </a:xfrm>
           <a:prstGeom prst="rect">
             <a:avLst/>
@@ -14139,70 +14168,79 @@
           <a:p>
             <a:pPr algn="l">
               <a:spcAft>
-                <a:spcPts val="400"/>
-              </a:spcAft>
-            </a:pPr>
-            <a:r>
-              <a:rPr sz="1600" b="1" i="0">
+                <a:spcPts val="200"/>
+              </a:spcAft>
+            </a:pPr>
+            <a:r>
+              <a:rPr sz="1400" b="1" i="1">
                 <a:solidFill>
                   <a:srgbClr val="1E1E1E"/>
                 </a:solidFill>
                 <a:latin typeface="Calibri"/>
               </a:rPr>
-              <a:t>A · Hata mı, kural mı?</a:t>
-            </a:r>
-          </a:p>
-        </p:txBody>
-      </p:sp>
-      <p:sp>
-        <p:nvSpPr>
-          <p:cNvPr id="11" name="TextBox 10"/>
-          <p:cNvSpPr txBox="1"/>
-          <p:nvPr/>
-        </p:nvSpPr>
-        <p:spPr>
-          <a:xfrm>
-            <a:off x="4174272" y="2148839"/>
-            <a:ext cx="1632167" cy="1188720"/>
-          </a:xfrm>
-          <a:prstGeom prst="rect">
-            <a:avLst/>
-          </a:prstGeom>
-          <a:noFill/>
-        </p:spPr>
-        <p:txBody>
-          <a:bodyPr wrap="square" anchor="t" lIns="0" rIns="0" tIns="0" bIns="0">
-            <a:spAutoFit/>
-          </a:bodyPr>
-          <a:lstStyle/>
+              <a:t>“ODMTTLMT ekranında hata alıyorum”</a:t>
+            </a:r>
+          </a:p>
           <a:p>
             <a:pPr algn="l">
               <a:spcAft>
-                <a:spcPts val="400"/>
-              </a:spcAft>
-            </a:pPr>
-            <a:r>
-              <a:rPr sz="1200" b="0" i="0">
+                <a:spcPts val="200"/>
+              </a:spcAft>
+            </a:pPr>
+            <a:r>
+              <a:rPr sz="1400" b="0" i="0">
                 <a:solidFill>
                   <a:srgbClr val="1E1E1E"/>
                 </a:solidFill>
                 <a:latin typeface="Calibri"/>
               </a:rPr>
-              <a:t>Elif yazmadan Mercek iş kuralını açıklıyor, 'Bana göster' ile 330.000 TL / 36 ay dolduruluyor. Çağrı açılmıyor.</a:t>
-            </a:r>
-          </a:p>
-        </p:txBody>
-      </p:sp>
-      <p:sp>
-        <p:nvSpPr>
-          <p:cNvPr id="12" name="Rounded Rectangle 11"/>
+              <a:t>Kendi logunda 7 hata · GAZ02 110731</a:t>
+            </a:r>
+          </a:p>
+          <a:p>
+            <a:pPr algn="l">
+              <a:spcAft>
+                <a:spcPts val="200"/>
+              </a:spcAft>
+            </a:pPr>
+            <a:r>
+              <a:rPr sz="1400" b="0" i="0">
+                <a:solidFill>
+                  <a:srgbClr val="1E1E1E"/>
+                </a:solidFill>
+                <a:latin typeface="Calibri"/>
+              </a:rPr>
+              <a:t>SOL-031 ile kapanmış 6 çağrı</a:t>
+            </a:r>
+          </a:p>
+          <a:p>
+            <a:pPr algn="l">
+              <a:spcAft>
+                <a:spcPts val="200"/>
+              </a:spcAft>
+            </a:pPr>
+            <a:r>
+              <a:rPr sz="1400" b="0" i="0">
+                <a:solidFill>
+                  <a:srgbClr val="1E1E1E"/>
+                </a:solidFill>
+                <a:latin typeface="Calibri"/>
+              </a:rPr>
+              <a:t>▶ Akışı izle: adım adım ekran turu</a:t>
+            </a:r>
+          </a:p>
+        </p:txBody>
+      </p:sp>
+      <p:sp>
+        <p:nvSpPr>
+          <p:cNvPr id="14" name="Rounded Rectangle 13"/>
           <p:cNvSpPr/>
           <p:nvPr/>
         </p:nvSpPr>
         <p:spPr>
           <a:xfrm>
-            <a:off x="6172200" y="1051560"/>
-            <a:ext cx="5577840" cy="2377440"/>
+            <a:off x="6172200" y="1188720"/>
+            <a:ext cx="5577840" cy="2331720"/>
           </a:xfrm>
           <a:prstGeom prst="roundRect">
             <a:avLst>
@@ -14223,9 +14261,37 @@
           <a:p/>
         </p:txBody>
       </p:sp>
+      <p:sp>
+        <p:nvSpPr>
+          <p:cNvPr id="15" name="Oval 14"/>
+          <p:cNvSpPr/>
+          <p:nvPr/>
+        </p:nvSpPr>
+        <p:spPr>
+          <a:xfrm>
+            <a:off x="6400800" y="1417320"/>
+            <a:ext cx="685800" cy="685800"/>
+          </a:xfrm>
+          <a:prstGeom prst="ellipse">
+            <a:avLst/>
+          </a:prstGeom>
+          <a:solidFill>
+            <a:srgbClr val="B90F0A"/>
+          </a:solidFill>
+          <a:ln>
+            <a:noFill/>
+          </a:ln>
+          <a:effectLst/>
+        </p:spPr>
+        <p:txBody>
+          <a:bodyPr rtlCol="0" anchor="ctr"/>
+          <a:lstStyle/>
+          <a:p/>
+        </p:txBody>
+      </p:sp>
       <p:pic>
         <p:nvPicPr>
-          <p:cNvPr id="13" name="Picture 12" descr="m-b-callcenter.png"/>
+          <p:cNvPr id="16" name="Picture 15" descr="eye-w.png"/>
           <p:cNvPicPr>
             <a:picLocks noChangeAspect="1"/>
           </p:cNvPicPr>
@@ -14239,28 +14305,78 @@
         </p:blipFill>
         <p:spPr>
           <a:xfrm>
-            <a:off x="6355080" y="1234439"/>
-            <a:ext cx="3397032" cy="2011680"/>
-          </a:xfrm>
-          <a:prstGeom prst="rect">
-            <a:avLst/>
-          </a:prstGeom>
-          <a:ln>
-            <a:solidFill>
-              <a:srgbClr val="B4BEC3"/>
-            </a:solidFill>
-          </a:ln>
+            <a:off x="6572250" y="1588770"/>
+            <a:ext cx="342900" cy="342900"/>
+          </a:xfrm>
+          <a:prstGeom prst="rect">
+            <a:avLst/>
+          </a:prstGeom>
         </p:spPr>
       </p:pic>
       <p:sp>
         <p:nvSpPr>
-          <p:cNvPr id="14" name="Rounded Rectangle 13"/>
+          <p:cNvPr id="17" name="TextBox 16"/>
+          <p:cNvSpPr txBox="1"/>
+          <p:nvPr/>
+        </p:nvSpPr>
+        <p:spPr>
+          <a:xfrm>
+            <a:off x="7269480" y="1389888"/>
+            <a:ext cx="3291839" cy="731520"/>
+          </a:xfrm>
+          <a:prstGeom prst="rect">
+            <a:avLst/>
+          </a:prstGeom>
+          <a:noFill/>
+        </p:spPr>
+        <p:txBody>
+          <a:bodyPr wrap="square" anchor="ctr" lIns="0" rIns="0" tIns="0" bIns="0">
+            <a:spAutoFit/>
+          </a:bodyPr>
+          <a:lstStyle/>
+          <a:p>
+            <a:pPr algn="l">
+              <a:spcAft>
+                <a:spcPts val="100"/>
+              </a:spcAft>
+            </a:pPr>
+            <a:r>
+              <a:rPr sz="1800" b="1" i="0">
+                <a:solidFill>
+                  <a:srgbClr val="1E1E1E"/>
+                </a:solidFill>
+                <a:latin typeface="Calibri"/>
+              </a:rPr>
+              <a:t>C · Belirtiyle arama</a:t>
+            </a:r>
+          </a:p>
+          <a:p>
+            <a:pPr algn="l">
+              <a:spcAft>
+                <a:spcPts val="100"/>
+              </a:spcAft>
+            </a:pPr>
+            <a:r>
+              <a:rPr sz="1200" b="0" i="0">
+                <a:solidFill>
+                  <a:srgbClr val="91969B"/>
+                </a:solidFill>
+                <a:latin typeface="Calibri"/>
+              </a:rPr>
+              <a:t>Elif → Kerem</a:t>
+            </a:r>
+          </a:p>
+        </p:txBody>
+      </p:sp>
+      <p:sp>
+        <p:nvSpPr>
+          <p:cNvPr id="18" name="Rounded Rectangle 17"/>
           <p:cNvSpPr/>
           <p:nvPr/>
         </p:nvSpPr>
         <p:spPr>
           <a:xfrm>
-            <a:off x="9934992" y="1234439"/>
+            <a:off x="10652760" y="1481328"/>
             <a:ext cx="868680" cy="310896"/>
           </a:xfrm>
           <a:prstGeom prst="roundRect">
@@ -14269,7 +14385,7 @@
             </a:avLst>
           </a:prstGeom>
           <a:solidFill>
-            <a:srgbClr val="E10514"/>
+            <a:srgbClr val="B90F0A"/>
           </a:solidFill>
           <a:ln>
             <a:noFill/>
@@ -14284,13 +14400,13 @@
       </p:sp>
       <p:sp>
         <p:nvSpPr>
-          <p:cNvPr id="15" name="TextBox 14"/>
+          <p:cNvPr id="19" name="TextBox 18"/>
           <p:cNvSpPr txBox="1"/>
           <p:nvPr/>
         </p:nvSpPr>
         <p:spPr>
           <a:xfrm>
-            <a:off x="9934992" y="1234439"/>
+            <a:off x="10652760" y="1481328"/>
             <a:ext cx="868680" cy="310896"/>
           </a:xfrm>
           <a:prstGeom prst="rect">
@@ -14316,21 +14432,21 @@
                 </a:solidFill>
                 <a:latin typeface="Calibri"/>
               </a:rPr>
-              <a:t>~50 sn</a:t>
-            </a:r>
-          </a:p>
-        </p:txBody>
-      </p:sp>
-      <p:sp>
-        <p:nvSpPr>
-          <p:cNvPr id="16" name="TextBox 15"/>
+              <a:t>~40 sn</a:t>
+            </a:r>
+          </a:p>
+        </p:txBody>
+      </p:sp>
+      <p:sp>
+        <p:nvSpPr>
+          <p:cNvPr id="20" name="TextBox 19"/>
           <p:cNvSpPr txBox="1"/>
           <p:nvPr/>
         </p:nvSpPr>
         <p:spPr>
           <a:xfrm>
-            <a:off x="9934992" y="1645919"/>
-            <a:ext cx="1632167" cy="502920"/>
+            <a:off x="6446520" y="2240280"/>
+            <a:ext cx="5029200" cy="1234440"/>
           </a:xfrm>
           <a:prstGeom prst="rect">
             <a:avLst/>
@@ -14345,70 +14461,79 @@
           <a:p>
             <a:pPr algn="l">
               <a:spcAft>
-                <a:spcPts val="400"/>
-              </a:spcAft>
-            </a:pPr>
-            <a:r>
-              <a:rPr sz="1600" b="1" i="0">
+                <a:spcPts val="200"/>
+              </a:spcAft>
+            </a:pPr>
+            <a:r>
+              <a:rPr sz="1400" b="1" i="1">
                 <a:solidFill>
                   <a:srgbClr val="1E1E1E"/>
                 </a:solidFill>
                 <a:latin typeface="Calibri"/>
               </a:rPr>
-              <a:t>B · Bilinen çözüm</a:t>
-            </a:r>
-          </a:p>
-        </p:txBody>
-      </p:sp>
-      <p:sp>
-        <p:nvSpPr>
-          <p:cNvPr id="17" name="TextBox 16"/>
-          <p:cNvSpPr txBox="1"/>
-          <p:nvPr/>
-        </p:nvSpPr>
-        <p:spPr>
-          <a:xfrm>
-            <a:off x="9934992" y="2148839"/>
-            <a:ext cx="1632167" cy="1188720"/>
-          </a:xfrm>
-          <a:prstGeom prst="rect">
-            <a:avLst/>
-          </a:prstGeom>
-          <a:noFill/>
-        </p:spPr>
-        <p:txBody>
-          <a:bodyPr wrap="square" anchor="t" lIns="0" rIns="0" tIns="0" bIns="0">
-            <a:spAutoFit/>
-          </a:bodyPr>
-          <a:lstStyle/>
+              <a:t>“abone numarasını sistem kabul etmiyor”</a:t>
+            </a:r>
+          </a:p>
           <a:p>
             <a:pPr algn="l">
               <a:spcAft>
-                <a:spcPts val="400"/>
-              </a:spcAft>
-            </a:pPr>
-            <a:r>
-              <a:rPr sz="1200" b="0" i="0">
+                <a:spcPts val="200"/>
+              </a:spcAft>
+            </a:pPr>
+            <a:r>
+              <a:rPr sz="1400" b="0" i="0">
                 <a:solidFill>
                   <a:srgbClr val="1E1E1E"/>
                 </a:solidFill>
                 <a:latin typeface="Calibri"/>
               </a:rPr>
-              <a:t>Zeynep'e müşteriye söylenecek metin; vaka CAG-2051'e bağlanıyor; Kerem'e %93 eşleşen çözüm.</a:t>
-            </a:r>
-          </a:p>
-        </p:txBody>
-      </p:sp>
-      <p:sp>
-        <p:nvSpPr>
-          <p:cNvPr id="18" name="Rounded Rectangle 17"/>
+              <a:t>AI Search: ODMTTLMT 110412 · İSKİ 13 hane</a:t>
+            </a:r>
+          </a:p>
+          <a:p>
+            <a:pPr algn="l">
+              <a:spcAft>
+                <a:spcPts val="200"/>
+              </a:spcAft>
+            </a:pPr>
+            <a:r>
+              <a:rPr sz="1400" b="0" i="0">
+                <a:solidFill>
+                  <a:srgbClr val="1E1E1E"/>
+                </a:solidFill>
+                <a:latin typeface="Calibri"/>
+              </a:rPr>
+              <a:t>7 günde 158 kayıt, tek kurumda</a:t>
+            </a:r>
+          </a:p>
+          <a:p>
+            <a:pPr algn="l">
+              <a:spcAft>
+                <a:spcPts val="200"/>
+              </a:spcAft>
+            </a:pPr>
+            <a:r>
+              <a:rPr sz="1400" b="0" i="0">
+                <a:solidFill>
+                  <a:srgbClr val="1E1E1E"/>
+                </a:solidFill>
+                <a:latin typeface="Calibri"/>
+              </a:rPr>
+              <a:t>‘Kullanıcı hatası’ çözümüne temkin</a:t>
+            </a:r>
+          </a:p>
+        </p:txBody>
+      </p:sp>
+      <p:sp>
+        <p:nvSpPr>
+          <p:cNvPr id="21" name="Rounded Rectangle 20"/>
           <p:cNvSpPr/>
           <p:nvPr/>
         </p:nvSpPr>
         <p:spPr>
           <a:xfrm>
-            <a:off x="411480" y="3566160"/>
-            <a:ext cx="5577840" cy="2377440"/>
+            <a:off x="411480" y="3703320"/>
+            <a:ext cx="5577840" cy="2331720"/>
           </a:xfrm>
           <a:prstGeom prst="roundRect">
             <a:avLst>
@@ -14429,9 +14554,37 @@
           <a:p/>
         </p:txBody>
       </p:sp>
+      <p:sp>
+        <p:nvSpPr>
+          <p:cNvPr id="22" name="Oval 21"/>
+          <p:cNvSpPr/>
+          <p:nvPr/>
+        </p:nvSpPr>
+        <p:spPr>
+          <a:xfrm>
+            <a:off x="640080" y="3931920"/>
+            <a:ext cx="685800" cy="685800"/>
+          </a:xfrm>
+          <a:prstGeom prst="ellipse">
+            <a:avLst/>
+          </a:prstGeom>
+          <a:solidFill>
+            <a:srgbClr val="870F00"/>
+          </a:solidFill>
+          <a:ln>
+            <a:noFill/>
+          </a:ln>
+          <a:effectLst/>
+        </p:spPr>
+        <p:txBody>
+          <a:bodyPr rtlCol="0" anchor="ctr"/>
+          <a:lstStyle/>
+          <a:p/>
+        </p:txBody>
+      </p:sp>
       <p:pic>
         <p:nvPicPr>
-          <p:cNvPr id="19" name="Picture 18" descr="m-c-code.png"/>
+          <p:cNvPr id="23" name="Picture 22" descr="users-w.png"/>
           <p:cNvPicPr>
             <a:picLocks noChangeAspect="1"/>
           </p:cNvPicPr>
@@ -14445,28 +14598,78 @@
         </p:blipFill>
         <p:spPr>
           <a:xfrm>
-            <a:off x="594360" y="3749039"/>
-            <a:ext cx="3397032" cy="2011680"/>
-          </a:xfrm>
-          <a:prstGeom prst="rect">
-            <a:avLst/>
-          </a:prstGeom>
-          <a:ln>
-            <a:solidFill>
-              <a:srgbClr val="B4BEC3"/>
-            </a:solidFill>
-          </a:ln>
+            <a:off x="811530" y="4103370"/>
+            <a:ext cx="342900" cy="342900"/>
+          </a:xfrm>
+          <a:prstGeom prst="rect">
+            <a:avLst/>
+          </a:prstGeom>
         </p:spPr>
       </p:pic>
       <p:sp>
         <p:nvSpPr>
-          <p:cNvPr id="20" name="Rounded Rectangle 19"/>
+          <p:cNvPr id="24" name="TextBox 23"/>
+          <p:cNvSpPr txBox="1"/>
+          <p:nvPr/>
+        </p:nvSpPr>
+        <p:spPr>
+          <a:xfrm>
+            <a:off x="1508760" y="3904487"/>
+            <a:ext cx="3291839" cy="731520"/>
+          </a:xfrm>
+          <a:prstGeom prst="rect">
+            <a:avLst/>
+          </a:prstGeom>
+          <a:noFill/>
+        </p:spPr>
+        <p:txBody>
+          <a:bodyPr wrap="square" anchor="ctr" lIns="0" rIns="0" tIns="0" bIns="0">
+            <a:spAutoFit/>
+          </a:bodyPr>
+          <a:lstStyle/>
+          <a:p>
+            <a:pPr algn="l">
+              <a:spcAft>
+                <a:spcPts val="100"/>
+              </a:spcAft>
+            </a:pPr>
+            <a:r>
+              <a:rPr sz="1800" b="1" i="0">
+                <a:solidFill>
+                  <a:srgbClr val="1E1E1E"/>
+                </a:solidFill>
+                <a:latin typeface="Calibri"/>
+              </a:rPr>
+              <a:t>D · Etkilenen müşteriler</a:t>
+            </a:r>
+          </a:p>
+          <a:p>
+            <a:pPr algn="l">
+              <a:spcAft>
+                <a:spcPts val="100"/>
+              </a:spcAft>
+            </a:pPr>
+            <a:r>
+              <a:rPr sz="1200" b="0" i="0">
+                <a:solidFill>
+                  <a:srgbClr val="91969B"/>
+                </a:solidFill>
+                <a:latin typeface="Calibri"/>
+              </a:rPr>
+              <a:t>Kerem (L2)</a:t>
+            </a:r>
+          </a:p>
+        </p:txBody>
+      </p:sp>
+      <p:sp>
+        <p:nvSpPr>
+          <p:cNvPr id="25" name="Rounded Rectangle 24"/>
           <p:cNvSpPr/>
           <p:nvPr/>
         </p:nvSpPr>
         <p:spPr>
           <a:xfrm>
-            <a:off x="4174272" y="3749039"/>
+            <a:off x="4892040" y="3995928"/>
             <a:ext cx="868680" cy="310896"/>
           </a:xfrm>
           <a:prstGeom prst="roundRect">
@@ -14475,7 +14678,7 @@
             </a:avLst>
           </a:prstGeom>
           <a:solidFill>
-            <a:srgbClr val="E10514"/>
+            <a:srgbClr val="870F00"/>
           </a:solidFill>
           <a:ln>
             <a:noFill/>
@@ -14490,13 +14693,13 @@
       </p:sp>
       <p:sp>
         <p:nvSpPr>
-          <p:cNvPr id="21" name="TextBox 20"/>
+          <p:cNvPr id="26" name="TextBox 25"/>
           <p:cNvSpPr txBox="1"/>
           <p:nvPr/>
         </p:nvSpPr>
         <p:spPr>
           <a:xfrm>
-            <a:off x="4174272" y="3749039"/>
+            <a:off x="4892040" y="3995928"/>
             <a:ext cx="868680" cy="310896"/>
           </a:xfrm>
           <a:prstGeom prst="rect">
@@ -14522,21 +14725,21 @@
                 </a:solidFill>
                 <a:latin typeface="Calibri"/>
               </a:rPr>
-              <a:t>~35 sn</a:t>
-            </a:r>
-          </a:p>
-        </p:txBody>
-      </p:sp>
-      <p:sp>
-        <p:nvSpPr>
-          <p:cNvPr id="22" name="TextBox 21"/>
+              <a:t>~40 sn</a:t>
+            </a:r>
+          </a:p>
+        </p:txBody>
+      </p:sp>
+      <p:sp>
+        <p:nvSpPr>
+          <p:cNvPr id="27" name="TextBox 26"/>
           <p:cNvSpPr txBox="1"/>
           <p:nvPr/>
         </p:nvSpPr>
         <p:spPr>
           <a:xfrm>
-            <a:off x="4174272" y="4160520"/>
-            <a:ext cx="1632167" cy="502920"/>
+            <a:off x="685800" y="4754879"/>
+            <a:ext cx="5029200" cy="1234440"/>
           </a:xfrm>
           <a:prstGeom prst="rect">
             <a:avLst/>
@@ -14551,70 +14754,79 @@
           <a:p>
             <a:pPr algn="l">
               <a:spcAft>
-                <a:spcPts val="400"/>
-              </a:spcAft>
-            </a:pPr>
-            <a:r>
-              <a:rPr sz="1600" b="1" i="0">
+                <a:spcPts val="200"/>
+              </a:spcAft>
+            </a:pPr>
+            <a:r>
+              <a:rPr sz="1400" b="1" i="1">
                 <a:solidFill>
                   <a:srgbClr val="1E1E1E"/>
                 </a:solidFill>
                 <a:latin typeface="Calibri"/>
               </a:rPr>
-              <a:t>C · Dış dünya değişti</a:t>
-            </a:r>
-          </a:p>
-        </p:txBody>
-      </p:sp>
-      <p:sp>
-        <p:nvSpPr>
-          <p:cNvPr id="23" name="TextBox 22"/>
-          <p:cNvSpPr txBox="1"/>
-          <p:nvPr/>
-        </p:nvSpPr>
-        <p:spPr>
-          <a:xfrm>
-            <a:off x="4174272" y="4663440"/>
-            <a:ext cx="1632167" cy="1188720"/>
-          </a:xfrm>
-          <a:prstGeom prst="rect">
-            <a:avLst/>
-          </a:prstGeom>
-          <a:noFill/>
-        </p:spPr>
-        <p:txBody>
-          <a:bodyPr wrap="square" anchor="t" lIns="0" rIns="0" tIns="0" bIns="0">
-            <a:spAutoFit/>
-          </a:bodyPr>
-          <a:lstStyle/>
+              <a:t>“Aktif talimat zaten var… kaç müşteri?”</a:t>
+            </a:r>
+          </a:p>
           <a:p>
             <a:pPr algn="l">
               <a:spcAft>
-                <a:spcPts val="400"/>
-              </a:spcAft>
-            </a:pPr>
-            <a:r>
-              <a:rPr sz="1200" b="0" i="0">
+                <a:spcPts val="200"/>
+              </a:spcAft>
+            </a:pPr>
+            <a:r>
+              <a:rPr sz="1400" b="0" i="0">
                 <a:solidFill>
                   <a:srgbClr val="1E1E1E"/>
                 </a:solidFill>
                 <a:latin typeface="Calibri"/>
               </a:rPr>
-              <a:t>412 hata, %97 İSKİ, 13 hane; İSKİ duyurusu; kuralın koddaki iki yeri ve düzeltme; ASKİ uyarısı.</a:t>
-            </a:r>
-          </a:p>
-        </p:txBody>
-      </p:sp>
-      <p:sp>
-        <p:nvSpPr>
-          <p:cNvPr id="24" name="Rounded Rectangle 23"/>
+              <a:t>Etkilenen müşteriler (31) düğmesi</a:t>
+            </a:r>
+          </a:p>
+          <a:p>
+            <a:pPr algn="l">
+              <a:spcAft>
+                <a:spcPts val="200"/>
+              </a:spcAft>
+            </a:pPr>
+            <a:r>
+              <a:rPr sz="1400" b="0" i="0">
+                <a:solidFill>
+                  <a:srgbClr val="1E1E1E"/>
+                </a:solidFill>
+                <a:latin typeface="Calibri"/>
+              </a:rPr>
+              <a:t>11 aranabilir; izinsiz telefon maskeli</a:t>
+            </a:r>
+          </a:p>
+          <a:p>
+            <a:pPr algn="l">
+              <a:spcAft>
+                <a:spcPts val="200"/>
+              </a:spcAft>
+            </a:pPr>
+            <a:r>
+              <a:rPr sz="1400" b="0" i="0">
+                <a:solidFill>
+                  <a:srgbClr val="1E1E1E"/>
+                </a:solidFill>
+                <a:latin typeface="Calibri"/>
+              </a:rPr>
+              <a:t>Görüntüleme erişim kaydına yazılır</a:t>
+            </a:r>
+          </a:p>
+        </p:txBody>
+      </p:sp>
+      <p:sp>
+        <p:nvSpPr>
+          <p:cNvPr id="28" name="Rounded Rectangle 27"/>
           <p:cNvSpPr/>
           <p:nvPr/>
         </p:nvSpPr>
         <p:spPr>
           <a:xfrm>
-            <a:off x="6172200" y="3566160"/>
-            <a:ext cx="5577840" cy="2377440"/>
+            <a:off x="6172200" y="3703320"/>
+            <a:ext cx="5577840" cy="2331720"/>
           </a:xfrm>
           <a:prstGeom prst="roundRect">
             <a:avLst>
@@ -14635,9 +14847,37 @@
           <a:p/>
         </p:txBody>
       </p:sp>
+      <p:sp>
+        <p:nvSpPr>
+          <p:cNvPr id="29" name="Oval 28"/>
+          <p:cNvSpPr/>
+          <p:nvPr/>
+        </p:nvSpPr>
+        <p:spPr>
+          <a:xfrm>
+            <a:off x="6400800" y="3931920"/>
+            <a:ext cx="685800" cy="685800"/>
+          </a:xfrm>
+          <a:prstGeom prst="ellipse">
+            <a:avLst/>
+          </a:prstGeom>
+          <a:solidFill>
+            <a:srgbClr val="91969B"/>
+          </a:solidFill>
+          <a:ln>
+            <a:noFill/>
+          </a:ln>
+          <a:effectLst/>
+        </p:spPr>
+        <p:txBody>
+          <a:bodyPr rtlCol="0" anchor="ctr"/>
+          <a:lstStyle/>
+          <a:p/>
+        </p:txBody>
+      </p:sp>
       <p:pic>
         <p:nvPicPr>
-          <p:cNvPr id="25" name="Picture 24" descr="m-d-request.png"/>
+          <p:cNvPr id="30" name="Picture 29" descr="shield-w.png"/>
           <p:cNvPicPr>
             <a:picLocks noChangeAspect="1"/>
           </p:cNvPicPr>
@@ -14651,28 +14891,78 @@
         </p:blipFill>
         <p:spPr>
           <a:xfrm>
-            <a:off x="6355080" y="3749039"/>
-            <a:ext cx="3397032" cy="2011680"/>
-          </a:xfrm>
-          <a:prstGeom prst="rect">
-            <a:avLst/>
-          </a:prstGeom>
-          <a:ln>
-            <a:solidFill>
-              <a:srgbClr val="B4BEC3"/>
-            </a:solidFill>
-          </a:ln>
+            <a:off x="6572250" y="4103370"/>
+            <a:ext cx="342900" cy="342900"/>
+          </a:xfrm>
+          <a:prstGeom prst="rect">
+            <a:avLst/>
+          </a:prstGeom>
         </p:spPr>
       </p:pic>
       <p:sp>
         <p:nvSpPr>
-          <p:cNvPr id="26" name="Rounded Rectangle 25"/>
+          <p:cNvPr id="31" name="TextBox 30"/>
+          <p:cNvSpPr txBox="1"/>
+          <p:nvPr/>
+        </p:nvSpPr>
+        <p:spPr>
+          <a:xfrm>
+            <a:off x="7269480" y="3904487"/>
+            <a:ext cx="3291839" cy="731520"/>
+          </a:xfrm>
+          <a:prstGeom prst="rect">
+            <a:avLst/>
+          </a:prstGeom>
+          <a:noFill/>
+        </p:spPr>
+        <p:txBody>
+          <a:bodyPr wrap="square" anchor="ctr" lIns="0" rIns="0" tIns="0" bIns="0">
+            <a:spAutoFit/>
+          </a:bodyPr>
+          <a:lstStyle/>
+          <a:p>
+            <a:pPr algn="l">
+              <a:spcAft>
+                <a:spcPts val="100"/>
+              </a:spcAft>
+            </a:pPr>
+            <a:r>
+              <a:rPr sz="1800" b="1" i="0">
+                <a:solidFill>
+                  <a:srgbClr val="1E1E1E"/>
+                </a:solidFill>
+                <a:latin typeface="Calibri"/>
+              </a:rPr>
+              <a:t>Güvenilir AI</a:t>
+            </a:r>
+          </a:p>
+          <a:p>
+            <a:pPr algn="l">
+              <a:spcAft>
+                <a:spcPts val="100"/>
+              </a:spcAft>
+            </a:pPr>
+            <a:r>
+              <a:rPr sz="1200" b="0" i="0">
+                <a:solidFill>
+                  <a:srgbClr val="91969B"/>
+                </a:solidFill>
+                <a:latin typeface="Calibri"/>
+              </a:rPr>
+              <a:t>Kerem (L2)</a:t>
+            </a:r>
+          </a:p>
+        </p:txBody>
+      </p:sp>
+      <p:sp>
+        <p:nvSpPr>
+          <p:cNvPr id="32" name="Rounded Rectangle 31"/>
           <p:cNvSpPr/>
           <p:nvPr/>
         </p:nvSpPr>
         <p:spPr>
           <a:xfrm>
-            <a:off x="9934992" y="3749039"/>
+            <a:off x="10652760" y="3995928"/>
             <a:ext cx="868680" cy="310896"/>
           </a:xfrm>
           <a:prstGeom prst="roundRect">
@@ -14681,7 +14971,7 @@
             </a:avLst>
           </a:prstGeom>
           <a:solidFill>
-            <a:srgbClr val="E10514"/>
+            <a:srgbClr val="91969B"/>
           </a:solidFill>
           <a:ln>
             <a:noFill/>
@@ -14696,13 +14986,13 @@
       </p:sp>
       <p:sp>
         <p:nvSpPr>
-          <p:cNvPr id="27" name="TextBox 26"/>
+          <p:cNvPr id="33" name="TextBox 32"/>
           <p:cNvSpPr txBox="1"/>
           <p:nvPr/>
         </p:nvSpPr>
         <p:spPr>
           <a:xfrm>
-            <a:off x="9934992" y="3749039"/>
+            <a:off x="10652760" y="3995928"/>
             <a:ext cx="868680" cy="310896"/>
           </a:xfrm>
           <a:prstGeom prst="rect">
@@ -14728,21 +15018,21 @@
                 </a:solidFill>
                 <a:latin typeface="Calibri"/>
               </a:rPr>
-              <a:t>~45 sn</a:t>
-            </a:r>
-          </a:p>
-        </p:txBody>
-      </p:sp>
-      <p:sp>
-        <p:nvSpPr>
-          <p:cNvPr id="28" name="TextBox 27"/>
+              <a:t>~35 sn</a:t>
+            </a:r>
+          </a:p>
+        </p:txBody>
+      </p:sp>
+      <p:sp>
+        <p:nvSpPr>
+          <p:cNvPr id="34" name="TextBox 33"/>
           <p:cNvSpPr txBox="1"/>
           <p:nvPr/>
         </p:nvSpPr>
         <p:spPr>
           <a:xfrm>
-            <a:off x="9934992" y="4160520"/>
-            <a:ext cx="1632167" cy="502920"/>
+            <a:off x="6446520" y="4754879"/>
+            <a:ext cx="5029200" cy="1234440"/>
           </a:xfrm>
           <a:prstGeom prst="rect">
             <a:avLst/>
@@ -14757,95 +15047,65 @@
           <a:p>
             <a:pPr algn="l">
               <a:spcAft>
-                <a:spcPts val="400"/>
-              </a:spcAft>
-            </a:pPr>
-            <a:r>
-              <a:rPr sz="1600" b="1" i="0">
+                <a:spcPts val="200"/>
+              </a:spcAft>
+            </a:pPr>
+            <a:r>
+              <a:rPr sz="1400" b="1" i="1">
                 <a:solidFill>
                   <a:srgbClr val="1E1E1E"/>
                 </a:solidFill>
                 <a:latin typeface="Calibri"/>
               </a:rPr>
-              <a:t>D · Talepten plana</a:t>
-            </a:r>
-          </a:p>
-        </p:txBody>
-      </p:sp>
-      <p:sp>
-        <p:nvSpPr>
-          <p:cNvPr id="29" name="TextBox 28"/>
-          <p:cNvSpPr txBox="1"/>
-          <p:nvPr/>
-        </p:nvSpPr>
-        <p:spPr>
-          <a:xfrm>
-            <a:off x="9934992" y="4663440"/>
-            <a:ext cx="1632167" cy="1188720"/>
-          </a:xfrm>
-          <a:prstGeom prst="rect">
-            <a:avLst/>
-          </a:prstGeom>
-          <a:noFill/>
-        </p:spPr>
-        <p:txBody>
-          <a:bodyPr wrap="square" anchor="t" lIns="0" rIns="0" tIns="0" bIns="0">
-            <a:spAutoFit/>
-          </a:bodyPr>
-          <a:lstStyle/>
+              <a:t>“Input string was not in a correct format”</a:t>
+            </a:r>
+          </a:p>
           <a:p>
             <a:pPr algn="l">
               <a:spcAft>
-                <a:spcPts val="400"/>
-              </a:spcAft>
-            </a:pPr>
-            <a:r>
-              <a:rPr sz="1200" b="0" i="0">
+                <a:spcPts val="200"/>
+              </a:spcAft>
+            </a:pPr>
+            <a:r>
+              <a:rPr sz="1400" b="0" i="0">
                 <a:solidFill>
                   <a:srgbClr val="1E1E1E"/>
                 </a:solidFill>
                 <a:latin typeface="Calibri"/>
               </a:rPr>
-              <a:t>KRDRTKSR'ye buton + batch işi, 18 a/g; SMS ile erişim %58 → %89, 20 a/g, 4 Aralık.</a:t>
-            </a:r>
-          </a:p>
-        </p:txBody>
-      </p:sp>
-      <p:sp>
-        <p:nvSpPr>
-          <p:cNvPr id="30" name="TextBox 29"/>
-          <p:cNvSpPr txBox="1"/>
-          <p:nvPr/>
-        </p:nvSpPr>
-        <p:spPr>
-          <a:xfrm>
-            <a:off x="411480" y="6108192"/>
-            <a:ext cx="6400800" cy="256032"/>
-          </a:xfrm>
-          <a:prstGeom prst="rect">
-            <a:avLst/>
-          </a:prstGeom>
-          <a:noFill/>
-        </p:spPr>
-        <p:txBody>
-          <a:bodyPr wrap="square" anchor="t" lIns="0" rIns="0" tIns="0" bIns="0">
-            <a:spAutoFit/>
-          </a:bodyPr>
-          <a:lstStyle/>
+              <a:t>Hazır çözüm araması: %75 eşiğin altında</a:t>
+            </a:r>
+          </a:p>
           <a:p>
             <a:pPr algn="l">
               <a:spcAft>
-                <a:spcPts val="400"/>
-              </a:spcAft>
-            </a:pPr>
-            <a:r>
-              <a:rPr sz="1100" b="0" i="1">
-                <a:solidFill>
-                  <a:srgbClr val="91969B"/>
-                </a:solidFill>
-                <a:latin typeface="Calibri"/>
-              </a:rPr>
-              <a:t>Taslak görsel — gerçek ekran görüntüsüyle değiştirilecek</a:t>
+                <a:spcPts val="200"/>
+              </a:spcAft>
+            </a:pPr>
+            <a:r>
+              <a:rPr sz="1400" b="0" i="0">
+                <a:solidFill>
+                  <a:srgbClr val="1E1E1E"/>
+                </a:solidFill>
+                <a:latin typeface="Calibri"/>
+              </a:rPr>
+              <a:t>Uydurmaz: ‘hazır çözüm yok, ekibe ilet’</a:t>
+            </a:r>
+          </a:p>
+          <a:p>
+            <a:pPr algn="l">
+              <a:spcAft>
+                <a:spcPts val="200"/>
+              </a:spcAft>
+            </a:pPr>
+            <a:r>
+              <a:rPr sz="1400" b="0" i="0">
+                <a:solidFill>
+                  <a:srgbClr val="1E1E1E"/>
+                </a:solidFill>
+                <a:latin typeface="Calibri"/>
+              </a:rPr>
+              <a:t>Foundry izlemesinde araç adımları</a:t>
             </a:r>
           </a:p>
         </p:txBody>
@@ -15158,7 +15418,7 @@
                 </a:solidFill>
                 <a:latin typeface="Calibri"/>
               </a:rPr>
-              <a:t>Onlarca arama → tek kayıt</a:t>
+              <a:t>Saniyeler içinde çözüm</a:t>
             </a:r>
           </a:p>
           <a:p>
@@ -15174,7 +15434,7 @@
                 </a:solidFill>
                 <a:latin typeface="Calibri"/>
               </a:rPr>
-              <a:t>Kurum kaynaklı sorunda (B)</a:t>
+              <a:t>Bilinen sorunda, kaynağıyla (B)</a:t>
             </a:r>
           </a:p>
         </p:txBody>
@@ -15243,7 +15503,7 @@
                 </a:solidFill>
                 <a:latin typeface="Calibri"/>
               </a:rPr>
-              <a:t>Toplantı → dakikalar</a:t>
+              <a:t>Tek tıkla liste</a:t>
             </a:r>
           </a:p>
           <a:p>
@@ -15259,7 +15519,7 @@
                 </a:solidFill>
                 <a:latin typeface="Calibri"/>
               </a:rPr>
-              <a:t>Talep analizi ve planı (D)</a:t>
+              <a:t>Etkilenen müşteri, KVKK uyumlu (D)</a:t>
             </a:r>
           </a:p>
         </p:txBody>
@@ -15410,7 +15670,7 @@
                           </a:solidFill>
                           <a:latin typeface="Calibri"/>
                         </a:rPr>
-                        <a:t>Ekranda açıklanır, uygun alternatif hesaplanır</a:t>
+                        <a:t>Mercek kuralı ve nedenini açıklar; çağrı açılmaz</a:t>
                       </a:r>
                     </a:p>
                   </a:txBody>
@@ -15478,7 +15738,7 @@
                           </a:solidFill>
                           <a:latin typeface="Calibri"/>
                         </a:rPr>
-                        <a:t>Tek ana kayıt, temsilciye hazır müşteri açıklaması</a:t>
+                        <a:t>Kurum kaynaklı olduğu, kaç kayıtta görüldüğüyle söylenir</a:t>
                       </a:r>
                     </a:p>
                   </a:txBody>
@@ -15546,7 +15806,7 @@
                           </a:solidFill>
                           <a:latin typeface="Calibri"/>
                         </a:rPr>
-                        <a:t>Kaynaklı eşleşen çözüm, saniyeler içinde</a:t>
+                        <a:t>Hazır çözüm ve ekran akışı; %75 eşiğin altında öneri yok</a:t>
                       </a:r>
                     </a:p>
                   </a:txBody>
@@ -15570,7 +15830,7 @@
                           </a:solidFill>
                           <a:latin typeface="Calibri"/>
                         </a:rPr>
-                        <a:t>Yeni sorun</a:t>
+                        <a:t>Yanlış kapatılan kural</a:t>
                       </a:r>
                     </a:p>
                   </a:txBody>
@@ -15592,7 +15852,7 @@
                           </a:solidFill>
                           <a:latin typeface="Calibri"/>
                         </a:rPr>
-                        <a:t>Kök neden günlerce aranır</a:t>
+                        <a:t>Kullanıcı hatası diye kapanır, tekrarlar</a:t>
                       </a:r>
                     </a:p>
                   </a:txBody>
@@ -15614,7 +15874,7 @@
                           </a:solidFill>
                           <a:latin typeface="Calibri"/>
                         </a:rPr>
-                        <a:t>Log + duyuru + kod; sonraki olay önceden görülür</a:t>
+                        <a:t>Tek kurumda yoğunlaşma işaretlenir, temkinli sunulur</a:t>
                       </a:r>
                     </a:p>
                   </a:txBody>
@@ -15638,7 +15898,7 @@
                           </a:solidFill>
                           <a:latin typeface="Calibri"/>
                         </a:rPr>
-                        <a:t>Talep planı</a:t>
+                        <a:t>Etkilenen müşteri</a:t>
                       </a:r>
                     </a:p>
                   </a:txBody>
@@ -15660,7 +15920,7 @@
                           </a:solidFill>
                           <a:latin typeface="Calibri"/>
                         </a:rPr>
-                        <a:t>Servisler ve erişim sorunu geç fark edilir</a:t>
+                        <a:t>Liste elle çıkarılır, izin bakılmaz</a:t>
                       </a:r>
                     </a:p>
                   </a:txBody>
@@ -15682,7 +15942,7 @@
                           </a:solidFill>
                           <a:latin typeface="Calibri"/>
                         </a:rPr>
-                        <a:t>Servis bazlı a/g ve takvim; kapsam veriyle düzeltilir</a:t>
+                        <a:t>L2 için tek tık; izinsiz numara maskeli, erişim kayıtlı</a:t>
                       </a:r>
                     </a:p>
                   </a:txBody>
@@ -15731,7 +15991,7 @@
                 </a:solidFill>
                 <a:latin typeface="Calibri"/>
               </a:rPr>
-              <a:t>Rakamlar sentetik veriye dayanır; demo sırasında Mercek'in sayaçları (önlenen çağrı, bağlanan vaka, analiz süresi) gösterilir.</a:t>
+              <a:t>Rakamlar sentetik veriye dayanır; her rakam Mercek'in araçlarından gelir ve Foundry izlemesinde doğrulanabilir.</a:t>
             </a:r>
           </a:p>
         </p:txBody>

</xml_diff>